<commit_message>
docs(G1-06): resolve plan review findings
</commit_message>
<xml_diff>
--- a/docs/work/A_PM/project_plan_v1_figures.pptx
+++ b/docs/work/A_PM/project_plan_v1_figures.pptx
@@ -2,16 +2,16 @@
 <file path=ppt/presentation.xml><?xml version="1.0" encoding="utf-8"?>
 <p:presentation xmlns:p="http://schemas.openxmlformats.org/presentationml/2006/main">
   <p:sldMasterIdLst>
-    <p:sldMasterId xmlns:r="http://schemas.openxmlformats.org/officeDocument/2006/relationships" id="2147483648" r:id="R4f6d35ac11c7419e"/>
+    <p:sldMasterId xmlns:r="http://schemas.openxmlformats.org/officeDocument/2006/relationships" id="2147483648" r:id="R62f2a1575a594693"/>
   </p:sldMasterIdLst>
   <p:notesMasterIdLst>
-    <p:notesMasterId xmlns:r="http://schemas.openxmlformats.org/officeDocument/2006/relationships" r:id="R63d9d4c779744ad5"/>
+    <p:notesMasterId xmlns:r="http://schemas.openxmlformats.org/officeDocument/2006/relationships" r:id="R8df43a0919b8437a"/>
   </p:notesMasterIdLst>
   <p:sldIdLst>
-    <p:sldId xmlns:r="http://schemas.openxmlformats.org/officeDocument/2006/relationships" id="256" r:id="Rf448ae8d29f848ee"/>
-    <p:sldId xmlns:r="http://schemas.openxmlformats.org/officeDocument/2006/relationships" id="257" r:id="R76b825ed58db4c3f"/>
-    <p:sldId xmlns:r="http://schemas.openxmlformats.org/officeDocument/2006/relationships" id="258" r:id="R6f1b339350e147df"/>
-    <p:sldId xmlns:r="http://schemas.openxmlformats.org/officeDocument/2006/relationships" id="259" r:id="Rf825abdaa94c45a1"/>
+    <p:sldId xmlns:r="http://schemas.openxmlformats.org/officeDocument/2006/relationships" id="256" r:id="R6c14f6484c5b456d"/>
+    <p:sldId xmlns:r="http://schemas.openxmlformats.org/officeDocument/2006/relationships" id="257" r:id="Rf98f5c115fdd469b"/>
+    <p:sldId xmlns:r="http://schemas.openxmlformats.org/officeDocument/2006/relationships" id="258" r:id="Red28ee4364834a3c"/>
+    <p:sldId xmlns:r="http://schemas.openxmlformats.org/officeDocument/2006/relationships" id="259" r:id="R03e577ee17364a68"/>
   </p:sldIdLst>
   <p:sldSz cx="12192000" cy="6858000"/>
   <p:notesSz cx="6858000" cy="9144000"/>
@@ -707,7 +707,7 @@
   </p:cSld>
   <p:clrMap bg1="lt1" tx1="dk1" bg2="lt2" tx2="dk2" accent1="accent1" accent2="accent2" accent3="accent3" accent4="accent4" accent5="accent5" accent6="accent6" hlink="hlink" folHlink="folHlink"/>
   <p:sldLayoutIdLst>
-    <p:sldLayoutId xmlns:r="http://schemas.openxmlformats.org/officeDocument/2006/relationships" id="2147483649" r:id="R489b4042a69c4cf9"/>
+    <p:sldLayoutId xmlns:r="http://schemas.openxmlformats.org/officeDocument/2006/relationships" id="2147483649" r:id="R8e90b53f0836407d"/>
   </p:sldLayoutIdLst>
   <p:txStyles>
     <p:titleStyle>
@@ -1258,7 +1258,7 @@
           <p:cNvPr id="48" name="">
             <a:extLst xmlns:a="http://schemas.openxmlformats.org/drawingml/2006/main">
               <a:ext uri="{FF2B5EF4-FFF2-40B4-BE49-F238E27FC236}">
-                <a16:creationId xmlns:a16="http://schemas.microsoft.com/office/drawing/2014/main" id="{D4D99E47-1923-4565-A436-0519EF250E53}"/>
+                <a16:creationId xmlns:a16="http://schemas.microsoft.com/office/drawing/2014/main" id="{6578024F-0D65-4159-A093-0EE83E37E248}"/>
               </a:ext>
             </a:extLst>
           </p:cNvPr>
@@ -1315,7 +1315,7 @@
           <p:cNvPr id="2" name="">
             <a:extLst xmlns:a="http://schemas.openxmlformats.org/drawingml/2006/main">
               <a:ext uri="{FF2B5EF4-FFF2-40B4-BE49-F238E27FC236}">
-                <a16:creationId xmlns:a16="http://schemas.microsoft.com/office/drawing/2014/main" id="{88296554-890F-46FE-8EA1-76D6189F23DC}"/>
+                <a16:creationId xmlns:a16="http://schemas.microsoft.com/office/drawing/2014/main" id="{BDE2D607-A9A1-46B3-8408-E1371436AC23}"/>
               </a:ext>
             </a:extLst>
           </p:cNvPr>
@@ -1372,7 +1372,7 @@
           <p:cNvPr id="3" name="">
             <a:extLst xmlns:a="http://schemas.openxmlformats.org/drawingml/2006/main">
               <a:ext uri="{FF2B5EF4-FFF2-40B4-BE49-F238E27FC236}">
-                <a16:creationId xmlns:a16="http://schemas.microsoft.com/office/drawing/2014/main" id="{4CFA21CA-D02E-4849-A21E-6C75E2FA92EA}"/>
+                <a16:creationId xmlns:a16="http://schemas.microsoft.com/office/drawing/2014/main" id="{C4D31341-BD7F-4CF7-87B6-7E2322511CB2}"/>
               </a:ext>
             </a:extLst>
           </p:cNvPr>
@@ -1402,7 +1402,7 @@
           <p:cNvPr id="4" name="">
             <a:extLst xmlns:a="http://schemas.openxmlformats.org/drawingml/2006/main">
               <a:ext uri="{FF2B5EF4-FFF2-40B4-BE49-F238E27FC236}">
-                <a16:creationId xmlns:a16="http://schemas.microsoft.com/office/drawing/2014/main" id="{7EDC1EC7-68CC-4F9B-B89F-018300FA67EB}"/>
+                <a16:creationId xmlns:a16="http://schemas.microsoft.com/office/drawing/2014/main" id="{760DAC57-A19B-445E-A255-5980C61518BD}"/>
               </a:ext>
             </a:extLst>
           </p:cNvPr>
@@ -1465,7 +1465,7 @@
           <p:cNvPr id="5" name="">
             <a:extLst xmlns:a="http://schemas.openxmlformats.org/drawingml/2006/main">
               <a:ext uri="{FF2B5EF4-FFF2-40B4-BE49-F238E27FC236}">
-                <a16:creationId xmlns:a16="http://schemas.microsoft.com/office/drawing/2014/main" id="{A9E35C1B-B765-4CF9-9D28-51EE3264AB04}"/>
+                <a16:creationId xmlns:a16="http://schemas.microsoft.com/office/drawing/2014/main" id="{E23EF71F-2E5B-45B8-9AC0-F15A9195F290}"/>
               </a:ext>
             </a:extLst>
           </p:cNvPr>
@@ -1495,7 +1495,7 @@
           <p:cNvPr id="6" name="">
             <a:extLst xmlns:a="http://schemas.openxmlformats.org/drawingml/2006/main">
               <a:ext uri="{FF2B5EF4-FFF2-40B4-BE49-F238E27FC236}">
-                <a16:creationId xmlns:a16="http://schemas.microsoft.com/office/drawing/2014/main" id="{E944A45A-AD22-4F84-93A8-599EFAC7D96F}"/>
+                <a16:creationId xmlns:a16="http://schemas.microsoft.com/office/drawing/2014/main" id="{D28B85BC-94D3-432E-8394-768466D4B0C0}"/>
               </a:ext>
             </a:extLst>
           </p:cNvPr>
@@ -1558,7 +1558,7 @@
           <p:cNvPr id="7" name="">
             <a:extLst xmlns:a="http://schemas.openxmlformats.org/drawingml/2006/main">
               <a:ext uri="{FF2B5EF4-FFF2-40B4-BE49-F238E27FC236}">
-                <a16:creationId xmlns:a16="http://schemas.microsoft.com/office/drawing/2014/main" id="{E864BABF-6863-49BA-94FC-3523802798F1}"/>
+                <a16:creationId xmlns:a16="http://schemas.microsoft.com/office/drawing/2014/main" id="{80A79B29-F8A4-4225-9ED6-15793BCA246C}"/>
               </a:ext>
             </a:extLst>
           </p:cNvPr>
@@ -1588,7 +1588,7 @@
           <p:cNvPr id="8" name="">
             <a:extLst xmlns:a="http://schemas.openxmlformats.org/drawingml/2006/main">
               <a:ext uri="{FF2B5EF4-FFF2-40B4-BE49-F238E27FC236}">
-                <a16:creationId xmlns:a16="http://schemas.microsoft.com/office/drawing/2014/main" id="{50F4B6EA-5BFA-4489-AAE9-E146A4B9826A}"/>
+                <a16:creationId xmlns:a16="http://schemas.microsoft.com/office/drawing/2014/main" id="{B2A4A57B-29BE-4BE2-8F2E-208CD7736EC8}"/>
               </a:ext>
             </a:extLst>
           </p:cNvPr>
@@ -1651,7 +1651,7 @@
           <p:cNvPr id="9" name="">
             <a:extLst xmlns:a="http://schemas.openxmlformats.org/drawingml/2006/main">
               <a:ext uri="{FF2B5EF4-FFF2-40B4-BE49-F238E27FC236}">
-                <a16:creationId xmlns:a16="http://schemas.microsoft.com/office/drawing/2014/main" id="{7B6E91B2-BBFC-45B1-939F-D49C0203E701}"/>
+                <a16:creationId xmlns:a16="http://schemas.microsoft.com/office/drawing/2014/main" id="{C2484C0A-CD8C-4FB9-BC7D-4409582FA76F}"/>
               </a:ext>
             </a:extLst>
           </p:cNvPr>
@@ -1681,7 +1681,7 @@
           <p:cNvPr id="10" name="">
             <a:extLst xmlns:a="http://schemas.openxmlformats.org/drawingml/2006/main">
               <a:ext uri="{FF2B5EF4-FFF2-40B4-BE49-F238E27FC236}">
-                <a16:creationId xmlns:a16="http://schemas.microsoft.com/office/drawing/2014/main" id="{6379ED64-657F-4B5B-BAD6-23702AC5ABE5}"/>
+                <a16:creationId xmlns:a16="http://schemas.microsoft.com/office/drawing/2014/main" id="{68AA8760-F904-48F8-8252-EFF3C60441DF}"/>
               </a:ext>
             </a:extLst>
           </p:cNvPr>
@@ -1744,7 +1744,7 @@
           <p:cNvPr id="11" name="">
             <a:extLst xmlns:a="http://schemas.openxmlformats.org/drawingml/2006/main">
               <a:ext uri="{FF2B5EF4-FFF2-40B4-BE49-F238E27FC236}">
-                <a16:creationId xmlns:a16="http://schemas.microsoft.com/office/drawing/2014/main" id="{31CCAFE7-FD42-4293-8862-609884CCD62A}"/>
+                <a16:creationId xmlns:a16="http://schemas.microsoft.com/office/drawing/2014/main" id="{AA832A54-4240-44B5-AA25-7048A504CFA9}"/>
               </a:ext>
             </a:extLst>
           </p:cNvPr>
@@ -1807,7 +1807,7 @@
           <p:cNvPr id="12" name="">
             <a:extLst xmlns:a="http://schemas.openxmlformats.org/drawingml/2006/main">
               <a:ext uri="{FF2B5EF4-FFF2-40B4-BE49-F238E27FC236}">
-                <a16:creationId xmlns:a16="http://schemas.microsoft.com/office/drawing/2014/main" id="{7A47E91B-FEAC-4A1C-989D-DC250BBBCE16}"/>
+                <a16:creationId xmlns:a16="http://schemas.microsoft.com/office/drawing/2014/main" id="{5502763E-4B54-4455-BC04-604953D881FC}"/>
               </a:ext>
             </a:extLst>
           </p:cNvPr>
@@ -1837,7 +1837,7 @@
           <p:cNvPr id="13" name="">
             <a:extLst xmlns:a="http://schemas.openxmlformats.org/drawingml/2006/main">
               <a:ext uri="{FF2B5EF4-FFF2-40B4-BE49-F238E27FC236}">
-                <a16:creationId xmlns:a16="http://schemas.microsoft.com/office/drawing/2014/main" id="{FFCE3CF8-2485-4AA3-B4FC-73404754ED1C}"/>
+                <a16:creationId xmlns:a16="http://schemas.microsoft.com/office/drawing/2014/main" id="{7A647FF5-B745-4B47-8CF9-262C6585538B}"/>
               </a:ext>
             </a:extLst>
           </p:cNvPr>
@@ -1900,7 +1900,7 @@
           <p:cNvPr id="14" name="">
             <a:extLst xmlns:a="http://schemas.openxmlformats.org/drawingml/2006/main">
               <a:ext uri="{FF2B5EF4-FFF2-40B4-BE49-F238E27FC236}">
-                <a16:creationId xmlns:a16="http://schemas.microsoft.com/office/drawing/2014/main" id="{C1ED9EB5-4EC0-42B4-83EC-5BFA7AADE4B4}"/>
+                <a16:creationId xmlns:a16="http://schemas.microsoft.com/office/drawing/2014/main" id="{D4B8A9E0-56EA-4314-B835-37EAD8722DFA}"/>
               </a:ext>
             </a:extLst>
           </p:cNvPr>
@@ -1930,7 +1930,7 @@
           <p:cNvPr id="15" name="">
             <a:extLst xmlns:a="http://schemas.openxmlformats.org/drawingml/2006/main">
               <a:ext uri="{FF2B5EF4-FFF2-40B4-BE49-F238E27FC236}">
-                <a16:creationId xmlns:a16="http://schemas.microsoft.com/office/drawing/2014/main" id="{13CD6931-BE63-4D93-A14B-C57E28CD8FC9}"/>
+                <a16:creationId xmlns:a16="http://schemas.microsoft.com/office/drawing/2014/main" id="{BBF87556-311F-42C9-A9AC-77A160F8F4E4}"/>
               </a:ext>
             </a:extLst>
           </p:cNvPr>
@@ -1993,7 +1993,7 @@
           <p:cNvPr id="16" name="">
             <a:extLst xmlns:a="http://schemas.openxmlformats.org/drawingml/2006/main">
               <a:ext uri="{FF2B5EF4-FFF2-40B4-BE49-F238E27FC236}">
-                <a16:creationId xmlns:a16="http://schemas.microsoft.com/office/drawing/2014/main" id="{2378B937-C6A0-48E1-97E9-2EDB666BBC06}"/>
+                <a16:creationId xmlns:a16="http://schemas.microsoft.com/office/drawing/2014/main" id="{F0EECC49-EA81-44ED-A8F0-A1722A91676A}"/>
               </a:ext>
             </a:extLst>
           </p:cNvPr>
@@ -2023,7 +2023,7 @@
           <p:cNvPr id="17" name="">
             <a:extLst xmlns:a="http://schemas.openxmlformats.org/drawingml/2006/main">
               <a:ext uri="{FF2B5EF4-FFF2-40B4-BE49-F238E27FC236}">
-                <a16:creationId xmlns:a16="http://schemas.microsoft.com/office/drawing/2014/main" id="{D866F43C-DB6B-4659-8EF8-BF7327F16B44}"/>
+                <a16:creationId xmlns:a16="http://schemas.microsoft.com/office/drawing/2014/main" id="{9C0048A5-1E50-422A-906C-C70F21DF8A28}"/>
               </a:ext>
             </a:extLst>
           </p:cNvPr>
@@ -2086,7 +2086,7 @@
           <p:cNvPr id="18" name="">
             <a:extLst xmlns:a="http://schemas.openxmlformats.org/drawingml/2006/main">
               <a:ext uri="{FF2B5EF4-FFF2-40B4-BE49-F238E27FC236}">
-                <a16:creationId xmlns:a16="http://schemas.microsoft.com/office/drawing/2014/main" id="{57D6C2DF-E7F3-49DF-84D8-F952A07FFFE8}"/>
+                <a16:creationId xmlns:a16="http://schemas.microsoft.com/office/drawing/2014/main" id="{A7836062-E93B-43D5-85A8-713585C4F807}"/>
               </a:ext>
             </a:extLst>
           </p:cNvPr>
@@ -2149,7 +2149,7 @@
           <p:cNvPr id="19" name="">
             <a:extLst xmlns:a="http://schemas.openxmlformats.org/drawingml/2006/main">
               <a:ext uri="{FF2B5EF4-FFF2-40B4-BE49-F238E27FC236}">
-                <a16:creationId xmlns:a16="http://schemas.microsoft.com/office/drawing/2014/main" id="{126EAA77-0983-420B-86FB-679FBD0C924E}"/>
+                <a16:creationId xmlns:a16="http://schemas.microsoft.com/office/drawing/2014/main" id="{2F213018-EAB3-4A58-B844-051E938561A9}"/>
               </a:ext>
             </a:extLst>
           </p:cNvPr>
@@ -2179,7 +2179,7 @@
           <p:cNvPr id="20" name="">
             <a:extLst xmlns:a="http://schemas.openxmlformats.org/drawingml/2006/main">
               <a:ext uri="{FF2B5EF4-FFF2-40B4-BE49-F238E27FC236}">
-                <a16:creationId xmlns:a16="http://schemas.microsoft.com/office/drawing/2014/main" id="{150890B7-2525-4C38-9E63-2D6C3BEA1949}"/>
+                <a16:creationId xmlns:a16="http://schemas.microsoft.com/office/drawing/2014/main" id="{D7E4756B-C7E6-4B20-983B-E5E7404F1AE6}"/>
               </a:ext>
             </a:extLst>
           </p:cNvPr>
@@ -2242,7 +2242,7 @@
           <p:cNvPr id="21" name="">
             <a:extLst xmlns:a="http://schemas.openxmlformats.org/drawingml/2006/main">
               <a:ext uri="{FF2B5EF4-FFF2-40B4-BE49-F238E27FC236}">
-                <a16:creationId xmlns:a16="http://schemas.microsoft.com/office/drawing/2014/main" id="{CDD1EF7E-7EE3-49CC-8BEB-CCB315633E52}"/>
+                <a16:creationId xmlns:a16="http://schemas.microsoft.com/office/drawing/2014/main" id="{DE4511DA-F19C-4105-8637-3D4E3671AF03}"/>
               </a:ext>
             </a:extLst>
           </p:cNvPr>
@@ -2272,7 +2272,7 @@
           <p:cNvPr id="22" name="">
             <a:extLst xmlns:a="http://schemas.openxmlformats.org/drawingml/2006/main">
               <a:ext uri="{FF2B5EF4-FFF2-40B4-BE49-F238E27FC236}">
-                <a16:creationId xmlns:a16="http://schemas.microsoft.com/office/drawing/2014/main" id="{8122125C-1626-43C0-92B6-B60802288079}"/>
+                <a16:creationId xmlns:a16="http://schemas.microsoft.com/office/drawing/2014/main" id="{402ECAF8-7FBD-4C8C-976F-4B68C795827F}"/>
               </a:ext>
             </a:extLst>
           </p:cNvPr>
@@ -2335,7 +2335,7 @@
           <p:cNvPr id="23" name="">
             <a:extLst xmlns:a="http://schemas.openxmlformats.org/drawingml/2006/main">
               <a:ext uri="{FF2B5EF4-FFF2-40B4-BE49-F238E27FC236}">
-                <a16:creationId xmlns:a16="http://schemas.microsoft.com/office/drawing/2014/main" id="{9872C384-3E79-4194-8ADE-670B3A7D2B40}"/>
+                <a16:creationId xmlns:a16="http://schemas.microsoft.com/office/drawing/2014/main" id="{18AA5440-5E26-42EB-B773-579CCAFEA2A2}"/>
               </a:ext>
             </a:extLst>
           </p:cNvPr>
@@ -2365,7 +2365,7 @@
           <p:cNvPr id="24" name="">
             <a:extLst xmlns:a="http://schemas.openxmlformats.org/drawingml/2006/main">
               <a:ext uri="{FF2B5EF4-FFF2-40B4-BE49-F238E27FC236}">
-                <a16:creationId xmlns:a16="http://schemas.microsoft.com/office/drawing/2014/main" id="{4A499C8D-EE1B-481A-927B-C673272DAC2E}"/>
+                <a16:creationId xmlns:a16="http://schemas.microsoft.com/office/drawing/2014/main" id="{0C23D37F-CE16-49EC-91AE-4B8C03BA358B}"/>
               </a:ext>
             </a:extLst>
           </p:cNvPr>
@@ -2428,7 +2428,7 @@
           <p:cNvPr id="25" name="">
             <a:extLst xmlns:a="http://schemas.openxmlformats.org/drawingml/2006/main">
               <a:ext uri="{FF2B5EF4-FFF2-40B4-BE49-F238E27FC236}">
-                <a16:creationId xmlns:a16="http://schemas.microsoft.com/office/drawing/2014/main" id="{8C859716-9CBA-42E7-A563-FE95D77BD24B}"/>
+                <a16:creationId xmlns:a16="http://schemas.microsoft.com/office/drawing/2014/main" id="{94340A7A-86E1-44B0-891C-2B899302E654}"/>
               </a:ext>
             </a:extLst>
           </p:cNvPr>
@@ -2491,7 +2491,7 @@
           <p:cNvPr id="26" name="">
             <a:extLst xmlns:a="http://schemas.openxmlformats.org/drawingml/2006/main">
               <a:ext uri="{FF2B5EF4-FFF2-40B4-BE49-F238E27FC236}">
-                <a16:creationId xmlns:a16="http://schemas.microsoft.com/office/drawing/2014/main" id="{042556BD-4AE5-407B-A698-2D869D86D129}"/>
+                <a16:creationId xmlns:a16="http://schemas.microsoft.com/office/drawing/2014/main" id="{53BFBC1B-8BA2-405F-B2CC-E9B3F72925E1}"/>
               </a:ext>
             </a:extLst>
           </p:cNvPr>
@@ -2521,7 +2521,7 @@
           <p:cNvPr id="27" name="">
             <a:extLst xmlns:a="http://schemas.openxmlformats.org/drawingml/2006/main">
               <a:ext uri="{FF2B5EF4-FFF2-40B4-BE49-F238E27FC236}">
-                <a16:creationId xmlns:a16="http://schemas.microsoft.com/office/drawing/2014/main" id="{E1EF74B7-8934-49EF-9EDE-242D02C240CB}"/>
+                <a16:creationId xmlns:a16="http://schemas.microsoft.com/office/drawing/2014/main" id="{082C7601-0D9B-4EDB-AF4F-0EBBCE4A9238}"/>
               </a:ext>
             </a:extLst>
           </p:cNvPr>
@@ -2584,7 +2584,7 @@
           <p:cNvPr id="28" name="">
             <a:extLst xmlns:a="http://schemas.openxmlformats.org/drawingml/2006/main">
               <a:ext uri="{FF2B5EF4-FFF2-40B4-BE49-F238E27FC236}">
-                <a16:creationId xmlns:a16="http://schemas.microsoft.com/office/drawing/2014/main" id="{4C16AE37-ECC4-4CA7-94EE-34870708132C}"/>
+                <a16:creationId xmlns:a16="http://schemas.microsoft.com/office/drawing/2014/main" id="{588B57D0-8588-40EA-8B91-0E6D11F20FFD}"/>
               </a:ext>
             </a:extLst>
           </p:cNvPr>
@@ -2614,7 +2614,7 @@
           <p:cNvPr id="29" name="">
             <a:extLst xmlns:a="http://schemas.openxmlformats.org/drawingml/2006/main">
               <a:ext uri="{FF2B5EF4-FFF2-40B4-BE49-F238E27FC236}">
-                <a16:creationId xmlns:a16="http://schemas.microsoft.com/office/drawing/2014/main" id="{0A537AFF-4E43-44EB-93DB-391567974DB2}"/>
+                <a16:creationId xmlns:a16="http://schemas.microsoft.com/office/drawing/2014/main" id="{E55B8E43-6D9E-48CC-B896-0082BE9E607B}"/>
               </a:ext>
             </a:extLst>
           </p:cNvPr>
@@ -2677,7 +2677,7 @@
           <p:cNvPr id="30" name="">
             <a:extLst xmlns:a="http://schemas.openxmlformats.org/drawingml/2006/main">
               <a:ext uri="{FF2B5EF4-FFF2-40B4-BE49-F238E27FC236}">
-                <a16:creationId xmlns:a16="http://schemas.microsoft.com/office/drawing/2014/main" id="{9D4AE7FD-6282-4476-AC49-899BADE290B3}"/>
+                <a16:creationId xmlns:a16="http://schemas.microsoft.com/office/drawing/2014/main" id="{EE723F13-495D-4D03-8C02-3957896D118E}"/>
               </a:ext>
             </a:extLst>
           </p:cNvPr>
@@ -2707,7 +2707,7 @@
           <p:cNvPr id="31" name="">
             <a:extLst xmlns:a="http://schemas.openxmlformats.org/drawingml/2006/main">
               <a:ext uri="{FF2B5EF4-FFF2-40B4-BE49-F238E27FC236}">
-                <a16:creationId xmlns:a16="http://schemas.microsoft.com/office/drawing/2014/main" id="{0F3BC86B-0B3D-40C1-B17E-31F79B9441F7}"/>
+                <a16:creationId xmlns:a16="http://schemas.microsoft.com/office/drawing/2014/main" id="{43EE6B3F-7A2D-407E-9E0F-D4D77487F405}"/>
               </a:ext>
             </a:extLst>
           </p:cNvPr>
@@ -2770,7 +2770,7 @@
           <p:cNvPr id="32" name="">
             <a:extLst xmlns:a="http://schemas.openxmlformats.org/drawingml/2006/main">
               <a:ext uri="{FF2B5EF4-FFF2-40B4-BE49-F238E27FC236}">
-                <a16:creationId xmlns:a16="http://schemas.microsoft.com/office/drawing/2014/main" id="{EB3C8D74-8D2D-4570-89DC-7C7041739EE5}"/>
+                <a16:creationId xmlns:a16="http://schemas.microsoft.com/office/drawing/2014/main" id="{BE1792D1-5826-43BA-91C1-6AFFC253CA40}"/>
               </a:ext>
             </a:extLst>
           </p:cNvPr>
@@ -2833,7 +2833,7 @@
           <p:cNvPr id="33" name="">
             <a:extLst xmlns:a="http://schemas.openxmlformats.org/drawingml/2006/main">
               <a:ext uri="{FF2B5EF4-FFF2-40B4-BE49-F238E27FC236}">
-                <a16:creationId xmlns:a16="http://schemas.microsoft.com/office/drawing/2014/main" id="{3A0D02A0-71C0-4F7E-BC03-28AA54D802FD}"/>
+                <a16:creationId xmlns:a16="http://schemas.microsoft.com/office/drawing/2014/main" id="{29B8D94A-88FB-4566-8F8B-B3C66B7C174C}"/>
               </a:ext>
             </a:extLst>
           </p:cNvPr>
@@ -2863,7 +2863,7 @@
           <p:cNvPr id="34" name="">
             <a:extLst xmlns:a="http://schemas.openxmlformats.org/drawingml/2006/main">
               <a:ext uri="{FF2B5EF4-FFF2-40B4-BE49-F238E27FC236}">
-                <a16:creationId xmlns:a16="http://schemas.microsoft.com/office/drawing/2014/main" id="{6FBDFEFC-FB00-458D-82C6-9CF1F890E736}"/>
+                <a16:creationId xmlns:a16="http://schemas.microsoft.com/office/drawing/2014/main" id="{2102383F-FDB4-4FD8-AC94-F95DF32C5194}"/>
               </a:ext>
             </a:extLst>
           </p:cNvPr>
@@ -2926,7 +2926,7 @@
           <p:cNvPr id="35" name="">
             <a:extLst xmlns:a="http://schemas.openxmlformats.org/drawingml/2006/main">
               <a:ext uri="{FF2B5EF4-FFF2-40B4-BE49-F238E27FC236}">
-                <a16:creationId xmlns:a16="http://schemas.microsoft.com/office/drawing/2014/main" id="{AC1EF25B-F1A5-4067-8E03-E0AFE52262B2}"/>
+                <a16:creationId xmlns:a16="http://schemas.microsoft.com/office/drawing/2014/main" id="{E3E70BD7-C063-4B3F-B976-E1CEF70F51F4}"/>
               </a:ext>
             </a:extLst>
           </p:cNvPr>
@@ -2956,7 +2956,7 @@
           <p:cNvPr id="36" name="">
             <a:extLst xmlns:a="http://schemas.openxmlformats.org/drawingml/2006/main">
               <a:ext uri="{FF2B5EF4-FFF2-40B4-BE49-F238E27FC236}">
-                <a16:creationId xmlns:a16="http://schemas.microsoft.com/office/drawing/2014/main" id="{39676526-3588-4B07-8C9B-72D6FE48F42B}"/>
+                <a16:creationId xmlns:a16="http://schemas.microsoft.com/office/drawing/2014/main" id="{B0069CAD-362B-47D3-A21B-1EE29B617ABF}"/>
               </a:ext>
             </a:extLst>
           </p:cNvPr>
@@ -3019,7 +3019,7 @@
           <p:cNvPr id="37" name="">
             <a:extLst xmlns:a="http://schemas.openxmlformats.org/drawingml/2006/main">
               <a:ext uri="{FF2B5EF4-FFF2-40B4-BE49-F238E27FC236}">
-                <a16:creationId xmlns:a16="http://schemas.microsoft.com/office/drawing/2014/main" id="{EA3228C1-97F1-4C02-8B9B-74DCB1A6CDCA}"/>
+                <a16:creationId xmlns:a16="http://schemas.microsoft.com/office/drawing/2014/main" id="{8274F7AA-8DC4-41D9-9706-CA01799E6AE0}"/>
               </a:ext>
             </a:extLst>
           </p:cNvPr>
@@ -3049,7 +3049,7 @@
           <p:cNvPr id="38" name="">
             <a:extLst xmlns:a="http://schemas.openxmlformats.org/drawingml/2006/main">
               <a:ext uri="{FF2B5EF4-FFF2-40B4-BE49-F238E27FC236}">
-                <a16:creationId xmlns:a16="http://schemas.microsoft.com/office/drawing/2014/main" id="{6471E6B4-1EF4-4588-AF24-A43197A5E69B}"/>
+                <a16:creationId xmlns:a16="http://schemas.microsoft.com/office/drawing/2014/main" id="{2F2A55E9-AC97-4BD0-A91B-D333B82ED506}"/>
               </a:ext>
             </a:extLst>
           </p:cNvPr>
@@ -3112,7 +3112,7 @@
           <p:cNvPr id="39" name="">
             <a:extLst xmlns:a="http://schemas.openxmlformats.org/drawingml/2006/main">
               <a:ext uri="{FF2B5EF4-FFF2-40B4-BE49-F238E27FC236}">
-                <a16:creationId xmlns:a16="http://schemas.microsoft.com/office/drawing/2014/main" id="{C058D59E-5505-49E2-9326-993873AEC1D8}"/>
+                <a16:creationId xmlns:a16="http://schemas.microsoft.com/office/drawing/2014/main" id="{CAF07D55-1EC3-4143-9AA8-62CF21E89546}"/>
               </a:ext>
             </a:extLst>
           </p:cNvPr>
@@ -3175,7 +3175,7 @@
           <p:cNvPr id="40" name="">
             <a:extLst xmlns:a="http://schemas.openxmlformats.org/drawingml/2006/main">
               <a:ext uri="{FF2B5EF4-FFF2-40B4-BE49-F238E27FC236}">
-                <a16:creationId xmlns:a16="http://schemas.microsoft.com/office/drawing/2014/main" id="{17C17727-D1A8-491F-8414-1CCAE27D5F88}"/>
+                <a16:creationId xmlns:a16="http://schemas.microsoft.com/office/drawing/2014/main" id="{86AFF6B0-B252-4409-8E3D-CCD2B53E66C8}"/>
               </a:ext>
             </a:extLst>
           </p:cNvPr>
@@ -3205,7 +3205,7 @@
           <p:cNvPr id="41" name="">
             <a:extLst xmlns:a="http://schemas.openxmlformats.org/drawingml/2006/main">
               <a:ext uri="{FF2B5EF4-FFF2-40B4-BE49-F238E27FC236}">
-                <a16:creationId xmlns:a16="http://schemas.microsoft.com/office/drawing/2014/main" id="{CC747C33-EC0F-413A-AF37-3E29C989B38C}"/>
+                <a16:creationId xmlns:a16="http://schemas.microsoft.com/office/drawing/2014/main" id="{F728B97C-3A4D-4C17-B1E1-32CCA6F774A7}"/>
               </a:ext>
             </a:extLst>
           </p:cNvPr>
@@ -3268,7 +3268,7 @@
           <p:cNvPr id="42" name="">
             <a:extLst xmlns:a="http://schemas.openxmlformats.org/drawingml/2006/main">
               <a:ext uri="{FF2B5EF4-FFF2-40B4-BE49-F238E27FC236}">
-                <a16:creationId xmlns:a16="http://schemas.microsoft.com/office/drawing/2014/main" id="{00EC21EF-EADE-4C00-B50B-E85092864B28}"/>
+                <a16:creationId xmlns:a16="http://schemas.microsoft.com/office/drawing/2014/main" id="{0B300D4C-C0CC-49F6-A672-B9180BFFE528}"/>
               </a:ext>
             </a:extLst>
           </p:cNvPr>
@@ -3298,7 +3298,7 @@
           <p:cNvPr id="43" name="">
             <a:extLst xmlns:a="http://schemas.openxmlformats.org/drawingml/2006/main">
               <a:ext uri="{FF2B5EF4-FFF2-40B4-BE49-F238E27FC236}">
-                <a16:creationId xmlns:a16="http://schemas.microsoft.com/office/drawing/2014/main" id="{C0C52F96-3A79-488D-88BE-18546F0FB683}"/>
+                <a16:creationId xmlns:a16="http://schemas.microsoft.com/office/drawing/2014/main" id="{56CDE984-64DE-4E18-81F2-B8C8D6D0050B}"/>
               </a:ext>
             </a:extLst>
           </p:cNvPr>
@@ -3361,7 +3361,7 @@
           <p:cNvPr id="44" name="">
             <a:extLst xmlns:a="http://schemas.openxmlformats.org/drawingml/2006/main">
               <a:ext uri="{FF2B5EF4-FFF2-40B4-BE49-F238E27FC236}">
-                <a16:creationId xmlns:a16="http://schemas.microsoft.com/office/drawing/2014/main" id="{60D02AEC-B9E1-4515-9D2D-AF460EAB50ED}"/>
+                <a16:creationId xmlns:a16="http://schemas.microsoft.com/office/drawing/2014/main" id="{1158C9A5-EA52-4E15-86D1-D9B61A020A91}"/>
               </a:ext>
             </a:extLst>
           </p:cNvPr>
@@ -3391,7 +3391,7 @@
           <p:cNvPr id="45" name="">
             <a:extLst xmlns:a="http://schemas.openxmlformats.org/drawingml/2006/main">
               <a:ext uri="{FF2B5EF4-FFF2-40B4-BE49-F238E27FC236}">
-                <a16:creationId xmlns:a16="http://schemas.microsoft.com/office/drawing/2014/main" id="{E7E2AFB7-C947-4A5B-9E30-DFB5AADEE566}"/>
+                <a16:creationId xmlns:a16="http://schemas.microsoft.com/office/drawing/2014/main" id="{393F5455-37C6-4287-BCD6-E7C3D8FA3BAD}"/>
               </a:ext>
             </a:extLst>
           </p:cNvPr>
@@ -3444,7 +3444,7 @@
                 <a:ea typeface="Microsoft YaHei"/>
                 <a:cs typeface="Microsoft YaHei"/>
               </a:rPr>
-              <a:t>M4与M5交付包</a:t>
+              <a:t>M4后M5与质保启动</a:t>
             </a:r>
           </a:p>
         </p:txBody>
@@ -3454,7 +3454,7 @@
           <p:cNvPr id="46" name="">
             <a:extLst xmlns:a="http://schemas.openxmlformats.org/drawingml/2006/main">
               <a:ext uri="{FF2B5EF4-FFF2-40B4-BE49-F238E27FC236}">
-                <a16:creationId xmlns:a16="http://schemas.microsoft.com/office/drawing/2014/main" id="{7DA1E528-FB71-4C59-BB47-01DB4582F041}"/>
+                <a16:creationId xmlns:a16="http://schemas.microsoft.com/office/drawing/2014/main" id="{7370908C-5907-45D7-9DCB-385FFD57FADD}"/>
               </a:ext>
             </a:extLst>
           </p:cNvPr>
@@ -3511,7 +3511,7 @@
           <p:cNvPr id="47" name="">
             <a:extLst xmlns:a="http://schemas.openxmlformats.org/drawingml/2006/main">
               <a:ext uri="{FF2B5EF4-FFF2-40B4-BE49-F238E27FC236}">
-                <a16:creationId xmlns:a16="http://schemas.microsoft.com/office/drawing/2014/main" id="{3691999F-C640-47AD-9A87-53983C475F57}"/>
+                <a16:creationId xmlns:a16="http://schemas.microsoft.com/office/drawing/2014/main" id="{730645D1-A02A-49D3-8273-CAF41EE09419}"/>
               </a:ext>
             </a:extLst>
           </p:cNvPr>
@@ -3566,7 +3566,7 @@
     </p:spTree>
     <p:extLst>
       <p:ext uri="{BB962C8B-B14F-4D97-AF65-F5344CB8AC3E}">
-        <p14:creationId xmlns:p14="http://schemas.microsoft.com/office/powerpoint/2010/main" val="1319219443"/>
+        <p14:creationId xmlns:p14="http://schemas.microsoft.com/office/powerpoint/2010/main" val="1187894733"/>
       </p:ext>
     </p:extLst>
   </p:cSld>
@@ -3597,7 +3597,7 @@
           <p:cNvPr id="32" name="">
             <a:extLst xmlns:a="http://schemas.openxmlformats.org/drawingml/2006/main">
               <a:ext uri="{FF2B5EF4-FFF2-40B4-BE49-F238E27FC236}">
-                <a16:creationId xmlns:a16="http://schemas.microsoft.com/office/drawing/2014/main" id="{C730C5D2-A9EF-48FE-9DAA-618768A81FFA}"/>
+                <a16:creationId xmlns:a16="http://schemas.microsoft.com/office/drawing/2014/main" id="{8035FE53-66B2-4C0F-8624-F0A273CCB275}"/>
               </a:ext>
             </a:extLst>
           </p:cNvPr>
@@ -3654,7 +3654,7 @@
           <p:cNvPr id="2" name="">
             <a:extLst xmlns:a="http://schemas.openxmlformats.org/drawingml/2006/main">
               <a:ext uri="{FF2B5EF4-FFF2-40B4-BE49-F238E27FC236}">
-                <a16:creationId xmlns:a16="http://schemas.microsoft.com/office/drawing/2014/main" id="{53E8B23F-31F0-4AF8-BE61-57F8B2C170B1}"/>
+                <a16:creationId xmlns:a16="http://schemas.microsoft.com/office/drawing/2014/main" id="{9394E4C3-B89C-4CC1-BC64-C2D15649F6EA}"/>
               </a:ext>
             </a:extLst>
           </p:cNvPr>
@@ -3711,7 +3711,7 @@
           <p:cNvPr id="3" name="">
             <a:extLst xmlns:a="http://schemas.openxmlformats.org/drawingml/2006/main">
               <a:ext uri="{FF2B5EF4-FFF2-40B4-BE49-F238E27FC236}">
-                <a16:creationId xmlns:a16="http://schemas.microsoft.com/office/drawing/2014/main" id="{C7705205-AAE2-49BE-9950-56A27A2929DA}"/>
+                <a16:creationId xmlns:a16="http://schemas.microsoft.com/office/drawing/2014/main" id="{D21CAFFD-4E0E-4F85-87FB-2879CEAD568E}"/>
               </a:ext>
             </a:extLst>
           </p:cNvPr>
@@ -3741,7 +3741,7 @@
           <p:cNvPr id="4" name="">
             <a:extLst xmlns:a="http://schemas.openxmlformats.org/drawingml/2006/main">
               <a:ext uri="{FF2B5EF4-FFF2-40B4-BE49-F238E27FC236}">
-                <a16:creationId xmlns:a16="http://schemas.microsoft.com/office/drawing/2014/main" id="{C014818F-7E6A-46BA-A053-52A35C218B2F}"/>
+                <a16:creationId xmlns:a16="http://schemas.microsoft.com/office/drawing/2014/main" id="{49AC5EF0-7DE0-489D-A1A8-9A56220DD26B}"/>
               </a:ext>
             </a:extLst>
           </p:cNvPr>
@@ -3771,7 +3771,7 @@
           <p:cNvPr id="5" name="">
             <a:extLst xmlns:a="http://schemas.openxmlformats.org/drawingml/2006/main">
               <a:ext uri="{FF2B5EF4-FFF2-40B4-BE49-F238E27FC236}">
-                <a16:creationId xmlns:a16="http://schemas.microsoft.com/office/drawing/2014/main" id="{6709CF8F-9BF5-46BE-B672-5A77A1DD4A6B}"/>
+                <a16:creationId xmlns:a16="http://schemas.microsoft.com/office/drawing/2014/main" id="{8CBA4BD8-78EC-4769-8387-A4D39FFB8C8F}"/>
               </a:ext>
             </a:extLst>
           </p:cNvPr>
@@ -3803,7 +3803,7 @@
           <p:cNvPr id="6" name="">
             <a:extLst xmlns:a="http://schemas.openxmlformats.org/drawingml/2006/main">
               <a:ext uri="{FF2B5EF4-FFF2-40B4-BE49-F238E27FC236}">
-                <a16:creationId xmlns:a16="http://schemas.microsoft.com/office/drawing/2014/main" id="{DEAECAD0-FC71-4070-B493-B1C32C3BF007}"/>
+                <a16:creationId xmlns:a16="http://schemas.microsoft.com/office/drawing/2014/main" id="{99D94B1F-D401-47E2-B130-D9C122CB37AB}"/>
               </a:ext>
             </a:extLst>
           </p:cNvPr>
@@ -3860,7 +3860,7 @@
           <p:cNvPr id="7" name="">
             <a:extLst xmlns:a="http://schemas.openxmlformats.org/drawingml/2006/main">
               <a:ext uri="{FF2B5EF4-FFF2-40B4-BE49-F238E27FC236}">
-                <a16:creationId xmlns:a16="http://schemas.microsoft.com/office/drawing/2014/main" id="{B49FF4E6-D8EE-4A81-9574-D96761A4D00B}"/>
+                <a16:creationId xmlns:a16="http://schemas.microsoft.com/office/drawing/2014/main" id="{5DF64490-D599-4BCD-84E1-96E08B7919E5}"/>
               </a:ext>
             </a:extLst>
           </p:cNvPr>
@@ -3917,7 +3917,7 @@
           <p:cNvPr id="8" name="">
             <a:extLst xmlns:a="http://schemas.openxmlformats.org/drawingml/2006/main">
               <a:ext uri="{FF2B5EF4-FFF2-40B4-BE49-F238E27FC236}">
-                <a16:creationId xmlns:a16="http://schemas.microsoft.com/office/drawing/2014/main" id="{2AB309FD-27D8-43E4-BA69-785ADF4DA952}"/>
+                <a16:creationId xmlns:a16="http://schemas.microsoft.com/office/drawing/2014/main" id="{8F2022E6-B91D-42BF-A4C3-D54B03E59569}"/>
               </a:ext>
             </a:extLst>
           </p:cNvPr>
@@ -3974,7 +3974,7 @@
           <p:cNvPr id="9" name="">
             <a:extLst xmlns:a="http://schemas.openxmlformats.org/drawingml/2006/main">
               <a:ext uri="{FF2B5EF4-FFF2-40B4-BE49-F238E27FC236}">
-                <a16:creationId xmlns:a16="http://schemas.microsoft.com/office/drawing/2014/main" id="{3778AB3C-FB31-4B89-898D-4B3756683037}"/>
+                <a16:creationId xmlns:a16="http://schemas.microsoft.com/office/drawing/2014/main" id="{28EEAF62-C11A-484A-A668-CC26029D4180}"/>
               </a:ext>
             </a:extLst>
           </p:cNvPr>
@@ -4060,7 +4060,7 @@
           <p:cNvPr id="10" name="">
             <a:extLst xmlns:a="http://schemas.openxmlformats.org/drawingml/2006/main">
               <a:ext uri="{FF2B5EF4-FFF2-40B4-BE49-F238E27FC236}">
-                <a16:creationId xmlns:a16="http://schemas.microsoft.com/office/drawing/2014/main" id="{650690DA-649A-4FA0-BEAB-521401711A06}"/>
+                <a16:creationId xmlns:a16="http://schemas.microsoft.com/office/drawing/2014/main" id="{5EF873DC-52BD-4DCC-8750-DE5422D76E3B}"/>
               </a:ext>
             </a:extLst>
           </p:cNvPr>
@@ -4092,7 +4092,7 @@
           <p:cNvPr id="11" name="">
             <a:extLst xmlns:a="http://schemas.openxmlformats.org/drawingml/2006/main">
               <a:ext uri="{FF2B5EF4-FFF2-40B4-BE49-F238E27FC236}">
-                <a16:creationId xmlns:a16="http://schemas.microsoft.com/office/drawing/2014/main" id="{9F08616E-AD4F-43FE-BD45-07366600F325}"/>
+                <a16:creationId xmlns:a16="http://schemas.microsoft.com/office/drawing/2014/main" id="{010CD6BD-7FDE-4F67-B49A-EFAA381F9E33}"/>
               </a:ext>
             </a:extLst>
           </p:cNvPr>
@@ -4149,7 +4149,7 @@
           <p:cNvPr id="12" name="">
             <a:extLst xmlns:a="http://schemas.openxmlformats.org/drawingml/2006/main">
               <a:ext uri="{FF2B5EF4-FFF2-40B4-BE49-F238E27FC236}">
-                <a16:creationId xmlns:a16="http://schemas.microsoft.com/office/drawing/2014/main" id="{5AF3254E-2A0A-4CC2-A31F-109036E15CC8}"/>
+                <a16:creationId xmlns:a16="http://schemas.microsoft.com/office/drawing/2014/main" id="{E44ED848-E851-4E55-803C-9E5A9CF8E176}"/>
               </a:ext>
             </a:extLst>
           </p:cNvPr>
@@ -4206,7 +4206,7 @@
           <p:cNvPr id="13" name="">
             <a:extLst xmlns:a="http://schemas.openxmlformats.org/drawingml/2006/main">
               <a:ext uri="{FF2B5EF4-FFF2-40B4-BE49-F238E27FC236}">
-                <a16:creationId xmlns:a16="http://schemas.microsoft.com/office/drawing/2014/main" id="{E3B9D7DE-4FE6-4105-BCE4-E19959D42795}"/>
+                <a16:creationId xmlns:a16="http://schemas.microsoft.com/office/drawing/2014/main" id="{7ED2571B-0D67-4EEC-AA2B-71867D73D7B2}"/>
               </a:ext>
             </a:extLst>
           </p:cNvPr>
@@ -4263,7 +4263,7 @@
           <p:cNvPr id="14" name="">
             <a:extLst xmlns:a="http://schemas.openxmlformats.org/drawingml/2006/main">
               <a:ext uri="{FF2B5EF4-FFF2-40B4-BE49-F238E27FC236}">
-                <a16:creationId xmlns:a16="http://schemas.microsoft.com/office/drawing/2014/main" id="{DA46F469-9B84-430F-BFE2-7B2D62F61632}"/>
+                <a16:creationId xmlns:a16="http://schemas.microsoft.com/office/drawing/2014/main" id="{1DA41504-6FA7-405F-ACB6-19FA4FB36B2F}"/>
               </a:ext>
             </a:extLst>
           </p:cNvPr>
@@ -4349,7 +4349,7 @@
           <p:cNvPr id="15" name="">
             <a:extLst xmlns:a="http://schemas.openxmlformats.org/drawingml/2006/main">
               <a:ext uri="{FF2B5EF4-FFF2-40B4-BE49-F238E27FC236}">
-                <a16:creationId xmlns:a16="http://schemas.microsoft.com/office/drawing/2014/main" id="{20281E27-0BAB-42DF-AE60-4EF0E7374A3C}"/>
+                <a16:creationId xmlns:a16="http://schemas.microsoft.com/office/drawing/2014/main" id="{37244FE4-E2EF-4BEF-A546-883F5475966C}"/>
               </a:ext>
             </a:extLst>
           </p:cNvPr>
@@ -4381,7 +4381,7 @@
           <p:cNvPr id="16" name="">
             <a:extLst xmlns:a="http://schemas.openxmlformats.org/drawingml/2006/main">
               <a:ext uri="{FF2B5EF4-FFF2-40B4-BE49-F238E27FC236}">
-                <a16:creationId xmlns:a16="http://schemas.microsoft.com/office/drawing/2014/main" id="{09F023B7-9EB1-48CF-850B-41E2D386DB04}"/>
+                <a16:creationId xmlns:a16="http://schemas.microsoft.com/office/drawing/2014/main" id="{2D97C0C6-EC3E-4BEB-ABDF-C804321F44A8}"/>
               </a:ext>
             </a:extLst>
           </p:cNvPr>
@@ -4438,7 +4438,7 @@
           <p:cNvPr id="17" name="">
             <a:extLst xmlns:a="http://schemas.openxmlformats.org/drawingml/2006/main">
               <a:ext uri="{FF2B5EF4-FFF2-40B4-BE49-F238E27FC236}">
-                <a16:creationId xmlns:a16="http://schemas.microsoft.com/office/drawing/2014/main" id="{FB71E02C-5632-43C8-B22E-EB71D20F187C}"/>
+                <a16:creationId xmlns:a16="http://schemas.microsoft.com/office/drawing/2014/main" id="{6CEF4425-C9C5-46FF-8478-B715DB34B6BA}"/>
               </a:ext>
             </a:extLst>
           </p:cNvPr>
@@ -4495,7 +4495,7 @@
           <p:cNvPr id="18" name="">
             <a:extLst xmlns:a="http://schemas.openxmlformats.org/drawingml/2006/main">
               <a:ext uri="{FF2B5EF4-FFF2-40B4-BE49-F238E27FC236}">
-                <a16:creationId xmlns:a16="http://schemas.microsoft.com/office/drawing/2014/main" id="{14E91D37-8C0F-442D-BDA7-DEA8F726EAFD}"/>
+                <a16:creationId xmlns:a16="http://schemas.microsoft.com/office/drawing/2014/main" id="{0943713D-A8C1-4BD9-87A6-418E14000203}"/>
               </a:ext>
             </a:extLst>
           </p:cNvPr>
@@ -4552,7 +4552,7 @@
           <p:cNvPr id="19" name="">
             <a:extLst xmlns:a="http://schemas.openxmlformats.org/drawingml/2006/main">
               <a:ext uri="{FF2B5EF4-FFF2-40B4-BE49-F238E27FC236}">
-                <a16:creationId xmlns:a16="http://schemas.microsoft.com/office/drawing/2014/main" id="{C3F9432E-880E-4DE5-B921-C55749CC8AC5}"/>
+                <a16:creationId xmlns:a16="http://schemas.microsoft.com/office/drawing/2014/main" id="{8D99772F-BB32-4AB6-A576-FBAD2EC6E708}"/>
               </a:ext>
             </a:extLst>
           </p:cNvPr>
@@ -4638,7 +4638,7 @@
           <p:cNvPr id="20" name="">
             <a:extLst xmlns:a="http://schemas.openxmlformats.org/drawingml/2006/main">
               <a:ext uri="{FF2B5EF4-FFF2-40B4-BE49-F238E27FC236}">
-                <a16:creationId xmlns:a16="http://schemas.microsoft.com/office/drawing/2014/main" id="{0D1AE606-0072-4607-AFDC-BB66F5D42DE3}"/>
+                <a16:creationId xmlns:a16="http://schemas.microsoft.com/office/drawing/2014/main" id="{FD6103F3-D61F-46B1-9199-93C7C30846F5}"/>
               </a:ext>
             </a:extLst>
           </p:cNvPr>
@@ -4670,7 +4670,7 @@
           <p:cNvPr id="21" name="">
             <a:extLst xmlns:a="http://schemas.openxmlformats.org/drawingml/2006/main">
               <a:ext uri="{FF2B5EF4-FFF2-40B4-BE49-F238E27FC236}">
-                <a16:creationId xmlns:a16="http://schemas.microsoft.com/office/drawing/2014/main" id="{DA76790A-F549-4546-A7CB-0643850DB664}"/>
+                <a16:creationId xmlns:a16="http://schemas.microsoft.com/office/drawing/2014/main" id="{684D648A-A643-4B3E-AB83-98299453F45E}"/>
               </a:ext>
             </a:extLst>
           </p:cNvPr>
@@ -4727,7 +4727,7 @@
           <p:cNvPr id="22" name="">
             <a:extLst xmlns:a="http://schemas.openxmlformats.org/drawingml/2006/main">
               <a:ext uri="{FF2B5EF4-FFF2-40B4-BE49-F238E27FC236}">
-                <a16:creationId xmlns:a16="http://schemas.microsoft.com/office/drawing/2014/main" id="{22CE2588-513D-439C-9C85-01B4437923D5}"/>
+                <a16:creationId xmlns:a16="http://schemas.microsoft.com/office/drawing/2014/main" id="{BAE1574D-B5A7-4F65-90D7-8E25B0B96C4B}"/>
               </a:ext>
             </a:extLst>
           </p:cNvPr>
@@ -4784,7 +4784,7 @@
           <p:cNvPr id="23" name="">
             <a:extLst xmlns:a="http://schemas.openxmlformats.org/drawingml/2006/main">
               <a:ext uri="{FF2B5EF4-FFF2-40B4-BE49-F238E27FC236}">
-                <a16:creationId xmlns:a16="http://schemas.microsoft.com/office/drawing/2014/main" id="{40F76557-FEFB-4EBC-B31A-A8D4CC0206D2}"/>
+                <a16:creationId xmlns:a16="http://schemas.microsoft.com/office/drawing/2014/main" id="{09107FFC-D51A-4A11-AA00-E9B42D024059}"/>
               </a:ext>
             </a:extLst>
           </p:cNvPr>
@@ -4841,7 +4841,7 @@
           <p:cNvPr id="24" name="">
             <a:extLst xmlns:a="http://schemas.openxmlformats.org/drawingml/2006/main">
               <a:ext uri="{FF2B5EF4-FFF2-40B4-BE49-F238E27FC236}">
-                <a16:creationId xmlns:a16="http://schemas.microsoft.com/office/drawing/2014/main" id="{992682AC-3F0F-4A85-A644-AE840B2397D4}"/>
+                <a16:creationId xmlns:a16="http://schemas.microsoft.com/office/drawing/2014/main" id="{5ADAAEEC-5BF1-448C-A652-2952B3B143B6}"/>
               </a:ext>
             </a:extLst>
           </p:cNvPr>
@@ -4894,7 +4894,7 @@
                 <a:ea typeface="Microsoft YaHei"/>
                 <a:cs typeface="Microsoft YaHei"/>
               </a:rPr>
-              <a:t>四周运行与缺陷记录</a:t>
+              <a:t>W17—W20逐周运行记录</a:t>
             </a:r>
           </a:p>
           <a:p xmlns:a="http://schemas.openxmlformats.org/drawingml/2006/main">
@@ -4927,7 +4927,7 @@
           <p:cNvPr id="25" name="">
             <a:extLst xmlns:a="http://schemas.openxmlformats.org/drawingml/2006/main">
               <a:ext uri="{FF2B5EF4-FFF2-40B4-BE49-F238E27FC236}">
-                <a16:creationId xmlns:a16="http://schemas.microsoft.com/office/drawing/2014/main" id="{0FE35151-2141-4C12-BE14-5F074E18738A}"/>
+                <a16:creationId xmlns:a16="http://schemas.microsoft.com/office/drawing/2014/main" id="{C65443A7-84B8-4EB2-B97A-7EC2734E1E1C}"/>
               </a:ext>
             </a:extLst>
           </p:cNvPr>
@@ -4959,7 +4959,7 @@
           <p:cNvPr id="26" name="">
             <a:extLst xmlns:a="http://schemas.openxmlformats.org/drawingml/2006/main">
               <a:ext uri="{FF2B5EF4-FFF2-40B4-BE49-F238E27FC236}">
-                <a16:creationId xmlns:a16="http://schemas.microsoft.com/office/drawing/2014/main" id="{751E9815-76E1-4A06-A7D3-402BBEA15C96}"/>
+                <a16:creationId xmlns:a16="http://schemas.microsoft.com/office/drawing/2014/main" id="{814C53F7-B136-4304-BFEB-4D869C9F68AA}"/>
               </a:ext>
             </a:extLst>
           </p:cNvPr>
@@ -5016,7 +5016,7 @@
           <p:cNvPr id="27" name="">
             <a:extLst xmlns:a="http://schemas.openxmlformats.org/drawingml/2006/main">
               <a:ext uri="{FF2B5EF4-FFF2-40B4-BE49-F238E27FC236}">
-                <a16:creationId xmlns:a16="http://schemas.microsoft.com/office/drawing/2014/main" id="{B770A953-07B0-4A34-9E3B-C1F5EE71699B}"/>
+                <a16:creationId xmlns:a16="http://schemas.microsoft.com/office/drawing/2014/main" id="{C39CF5E8-D885-4607-B95F-5D4D42E42C50}"/>
               </a:ext>
             </a:extLst>
           </p:cNvPr>
@@ -5073,7 +5073,7 @@
           <p:cNvPr id="28" name="">
             <a:extLst xmlns:a="http://schemas.openxmlformats.org/drawingml/2006/main">
               <a:ext uri="{FF2B5EF4-FFF2-40B4-BE49-F238E27FC236}">
-                <a16:creationId xmlns:a16="http://schemas.microsoft.com/office/drawing/2014/main" id="{C87A2E29-B2F8-4B61-94A7-2EB8C927F181}"/>
+                <a16:creationId xmlns:a16="http://schemas.microsoft.com/office/drawing/2014/main" id="{81B84CAC-24BF-4D3C-8C71-ADAAA80FB540}"/>
               </a:ext>
             </a:extLst>
           </p:cNvPr>
@@ -5130,7 +5130,7 @@
           <p:cNvPr id="29" name="">
             <a:extLst xmlns:a="http://schemas.openxmlformats.org/drawingml/2006/main">
               <a:ext uri="{FF2B5EF4-FFF2-40B4-BE49-F238E27FC236}">
-                <a16:creationId xmlns:a16="http://schemas.microsoft.com/office/drawing/2014/main" id="{FD77237A-0F1E-4D41-8223-790173981BD1}"/>
+                <a16:creationId xmlns:a16="http://schemas.microsoft.com/office/drawing/2014/main" id="{C9115D9E-CC3D-47B0-8743-D04689CD9B06}"/>
               </a:ext>
             </a:extLst>
           </p:cNvPr>
@@ -5183,7 +5183,7 @@
                 <a:ea typeface="Microsoft YaHei"/>
                 <a:cs typeface="Microsoft YaHei"/>
               </a:rPr>
-              <a:t>全套交付物</a:t>
+              <a:t>M4准出后组织</a:t>
             </a:r>
           </a:p>
           <a:p xmlns:a="http://schemas.openxmlformats.org/drawingml/2006/main">
@@ -5206,7 +5206,7 @@
                 <a:ea typeface="Microsoft YaHei"/>
                 <a:cs typeface="Microsoft YaHei"/>
               </a:rPr>
-              <a:t>验收通过并签署报告</a:t>
+              <a:t>全套交付物并签署报告</a:t>
             </a:r>
           </a:p>
         </p:txBody>
@@ -5216,7 +5216,7 @@
           <p:cNvPr id="30" name="">
             <a:extLst xmlns:a="http://schemas.openxmlformats.org/drawingml/2006/main">
               <a:ext uri="{FF2B5EF4-FFF2-40B4-BE49-F238E27FC236}">
-                <a16:creationId xmlns:a16="http://schemas.microsoft.com/office/drawing/2014/main" id="{6B1702B4-0550-4C07-9181-C6F059623B71}"/>
+                <a16:creationId xmlns:a16="http://schemas.microsoft.com/office/drawing/2014/main" id="{7DB83223-AFC0-4B9C-A219-0A1129B72AC4}"/>
               </a:ext>
             </a:extLst>
           </p:cNvPr>
@@ -5269,7 +5269,7 @@
                 <a:ea typeface="Microsoft YaHei"/>
                 <a:cs typeface="Microsoft YaHei"/>
               </a:rPr>
-              <a:t>M4 与 M5 均受“试运行满一个月”条件约束。W20 先完成试运行准出证据，再组织竣工验收；甲方验收窗口变化只调整日历日期，不降低准出条件。</a:t>
+              <a:t>W17—W20均形成运行监测、工单、缺陷和可用率证据。W20先完成M4试运行准出，再组织M5竣工验收；甲方验收窗口变化不降低准出条件。</a:t>
             </a:r>
           </a:p>
         </p:txBody>
@@ -5279,7 +5279,7 @@
           <p:cNvPr id="31" name="">
             <a:extLst xmlns:a="http://schemas.openxmlformats.org/drawingml/2006/main">
               <a:ext uri="{FF2B5EF4-FFF2-40B4-BE49-F238E27FC236}">
-                <a16:creationId xmlns:a16="http://schemas.microsoft.com/office/drawing/2014/main" id="{FA618DEE-99D4-46F4-A63A-6E82FD53A532}"/>
+                <a16:creationId xmlns:a16="http://schemas.microsoft.com/office/drawing/2014/main" id="{2BD612E1-D826-4660-A238-C43EC4ECE3CB}"/>
               </a:ext>
             </a:extLst>
           </p:cNvPr>
@@ -5334,7 +5334,7 @@
     </p:spTree>
     <p:extLst>
       <p:ext uri="{BB962C8B-B14F-4D97-AF65-F5344CB8AC3E}">
-        <p14:creationId xmlns:p14="http://schemas.microsoft.com/office/powerpoint/2010/main" val="604688950"/>
+        <p14:creationId xmlns:p14="http://schemas.microsoft.com/office/powerpoint/2010/main" val="1617748455"/>
       </p:ext>
     </p:extLst>
   </p:cSld>
@@ -5365,7 +5365,7 @@
           <p:cNvPr id="94" name="">
             <a:extLst xmlns:a="http://schemas.openxmlformats.org/drawingml/2006/main">
               <a:ext uri="{FF2B5EF4-FFF2-40B4-BE49-F238E27FC236}">
-                <a16:creationId xmlns:a16="http://schemas.microsoft.com/office/drawing/2014/main" id="{AA118C2A-A905-4EBD-AF6C-3316D1769A74}"/>
+                <a16:creationId xmlns:a16="http://schemas.microsoft.com/office/drawing/2014/main" id="{B31E213F-D691-459E-95DA-E5E134ECAF84}"/>
               </a:ext>
             </a:extLst>
           </p:cNvPr>
@@ -5422,7 +5422,7 @@
           <p:cNvPr id="2" name="">
             <a:extLst xmlns:a="http://schemas.openxmlformats.org/drawingml/2006/main">
               <a:ext uri="{FF2B5EF4-FFF2-40B4-BE49-F238E27FC236}">
-                <a16:creationId xmlns:a16="http://schemas.microsoft.com/office/drawing/2014/main" id="{DA9A3973-54EE-4A91-B77D-2983B322DFFF}"/>
+                <a16:creationId xmlns:a16="http://schemas.microsoft.com/office/drawing/2014/main" id="{69C0AAE9-1C77-4512-9C8E-2CFFC618AE16}"/>
               </a:ext>
             </a:extLst>
           </p:cNvPr>
@@ -5479,7 +5479,7 @@
           <p:cNvPr id="3" name="">
             <a:extLst xmlns:a="http://schemas.openxmlformats.org/drawingml/2006/main">
               <a:ext uri="{FF2B5EF4-FFF2-40B4-BE49-F238E27FC236}">
-                <a16:creationId xmlns:a16="http://schemas.microsoft.com/office/drawing/2014/main" id="{28FD9C64-3274-4806-BB69-3A2BFDF18016}"/>
+                <a16:creationId xmlns:a16="http://schemas.microsoft.com/office/drawing/2014/main" id="{496ADE12-EE4F-4C9E-8778-F8F5CEF7F9F2}"/>
               </a:ext>
             </a:extLst>
           </p:cNvPr>
@@ -5509,7 +5509,7 @@
           <p:cNvPr id="4" name="">
             <a:extLst xmlns:a="http://schemas.openxmlformats.org/drawingml/2006/main">
               <a:ext uri="{FF2B5EF4-FFF2-40B4-BE49-F238E27FC236}">
-                <a16:creationId xmlns:a16="http://schemas.microsoft.com/office/drawing/2014/main" id="{E1C4C27A-E9A5-4E79-BD66-4EA9123D71A9}"/>
+                <a16:creationId xmlns:a16="http://schemas.microsoft.com/office/drawing/2014/main" id="{25E80725-981F-44F2-ABC6-F2538F6119A5}"/>
               </a:ext>
             </a:extLst>
           </p:cNvPr>
@@ -5566,7 +5566,7 @@
           <p:cNvPr id="5" name="">
             <a:extLst xmlns:a="http://schemas.openxmlformats.org/drawingml/2006/main">
               <a:ext uri="{FF2B5EF4-FFF2-40B4-BE49-F238E27FC236}">
-                <a16:creationId xmlns:a16="http://schemas.microsoft.com/office/drawing/2014/main" id="{F6C73679-1173-4557-83C4-159E3B4FD8C1}"/>
+                <a16:creationId xmlns:a16="http://schemas.microsoft.com/office/drawing/2014/main" id="{C934F80D-B375-44A8-8374-16B32D842FC5}"/>
               </a:ext>
             </a:extLst>
           </p:cNvPr>
@@ -5623,7 +5623,7 @@
           <p:cNvPr id="6" name="">
             <a:extLst xmlns:a="http://schemas.openxmlformats.org/drawingml/2006/main">
               <a:ext uri="{FF2B5EF4-FFF2-40B4-BE49-F238E27FC236}">
-                <a16:creationId xmlns:a16="http://schemas.microsoft.com/office/drawing/2014/main" id="{D6186CDB-6DB3-48AD-A35B-59F3C387D122}"/>
+                <a16:creationId xmlns:a16="http://schemas.microsoft.com/office/drawing/2014/main" id="{A64CDE9D-8DB8-4D6B-B4C4-A219E0E35F92}"/>
               </a:ext>
             </a:extLst>
           </p:cNvPr>
@@ -5653,7 +5653,7 @@
           <p:cNvPr id="7" name="">
             <a:extLst xmlns:a="http://schemas.openxmlformats.org/drawingml/2006/main">
               <a:ext uri="{FF2B5EF4-FFF2-40B4-BE49-F238E27FC236}">
-                <a16:creationId xmlns:a16="http://schemas.microsoft.com/office/drawing/2014/main" id="{51F97618-167D-4512-A2F5-8ECEFFE8C3E8}"/>
+                <a16:creationId xmlns:a16="http://schemas.microsoft.com/office/drawing/2014/main" id="{F7B72E4B-3A77-471D-A3A2-709CFE57C938}"/>
               </a:ext>
             </a:extLst>
           </p:cNvPr>
@@ -5710,7 +5710,7 @@
           <p:cNvPr id="8" name="">
             <a:extLst xmlns:a="http://schemas.openxmlformats.org/drawingml/2006/main">
               <a:ext uri="{FF2B5EF4-FFF2-40B4-BE49-F238E27FC236}">
-                <a16:creationId xmlns:a16="http://schemas.microsoft.com/office/drawing/2014/main" id="{49FC3C94-F9CE-4EC1-9336-531724300337}"/>
+                <a16:creationId xmlns:a16="http://schemas.microsoft.com/office/drawing/2014/main" id="{60E94BC2-D06F-44EA-97D4-440D744FE449}"/>
               </a:ext>
             </a:extLst>
           </p:cNvPr>
@@ -5740,7 +5740,7 @@
           <p:cNvPr id="9" name="">
             <a:extLst xmlns:a="http://schemas.openxmlformats.org/drawingml/2006/main">
               <a:ext uri="{FF2B5EF4-FFF2-40B4-BE49-F238E27FC236}">
-                <a16:creationId xmlns:a16="http://schemas.microsoft.com/office/drawing/2014/main" id="{2347D172-BA3A-497C-99BF-A0FB7982E427}"/>
+                <a16:creationId xmlns:a16="http://schemas.microsoft.com/office/drawing/2014/main" id="{532F8B6E-9F87-42BA-A184-39E6F4745B17}"/>
               </a:ext>
             </a:extLst>
           </p:cNvPr>
@@ -5797,7 +5797,7 @@
           <p:cNvPr id="10" name="">
             <a:extLst xmlns:a="http://schemas.openxmlformats.org/drawingml/2006/main">
               <a:ext uri="{FF2B5EF4-FFF2-40B4-BE49-F238E27FC236}">
-                <a16:creationId xmlns:a16="http://schemas.microsoft.com/office/drawing/2014/main" id="{54EE4073-E2C7-4CB2-A009-45435AB4F7F6}"/>
+                <a16:creationId xmlns:a16="http://schemas.microsoft.com/office/drawing/2014/main" id="{1A03C89A-F4A9-4849-8C71-725EC1C244F0}"/>
               </a:ext>
             </a:extLst>
           </p:cNvPr>
@@ -5827,7 +5827,7 @@
           <p:cNvPr id="11" name="">
             <a:extLst xmlns:a="http://schemas.openxmlformats.org/drawingml/2006/main">
               <a:ext uri="{FF2B5EF4-FFF2-40B4-BE49-F238E27FC236}">
-                <a16:creationId xmlns:a16="http://schemas.microsoft.com/office/drawing/2014/main" id="{0BDCA595-2EDB-4B4C-BD0C-2F2C40AD53A1}"/>
+                <a16:creationId xmlns:a16="http://schemas.microsoft.com/office/drawing/2014/main" id="{6AD9B0A4-42D3-4062-8533-B2534B172EA2}"/>
               </a:ext>
             </a:extLst>
           </p:cNvPr>
@@ -5884,7 +5884,7 @@
           <p:cNvPr id="12" name="">
             <a:extLst xmlns:a="http://schemas.openxmlformats.org/drawingml/2006/main">
               <a:ext uri="{FF2B5EF4-FFF2-40B4-BE49-F238E27FC236}">
-                <a16:creationId xmlns:a16="http://schemas.microsoft.com/office/drawing/2014/main" id="{27438A4C-51D4-4373-B0FC-01CAB4B2DC34}"/>
+                <a16:creationId xmlns:a16="http://schemas.microsoft.com/office/drawing/2014/main" id="{12961A2D-18BB-44F4-AED7-2DC84A85B9AB}"/>
               </a:ext>
             </a:extLst>
           </p:cNvPr>
@@ -5914,7 +5914,7 @@
           <p:cNvPr id="13" name="">
             <a:extLst xmlns:a="http://schemas.openxmlformats.org/drawingml/2006/main">
               <a:ext uri="{FF2B5EF4-FFF2-40B4-BE49-F238E27FC236}">
-                <a16:creationId xmlns:a16="http://schemas.microsoft.com/office/drawing/2014/main" id="{3BD275A9-832B-4632-9FE1-A3D64DA636D0}"/>
+                <a16:creationId xmlns:a16="http://schemas.microsoft.com/office/drawing/2014/main" id="{8A2F0FD6-93A3-4A4D-9AC7-B1260DD15AC1}"/>
               </a:ext>
             </a:extLst>
           </p:cNvPr>
@@ -5971,7 +5971,7 @@
           <p:cNvPr id="14" name="">
             <a:extLst xmlns:a="http://schemas.openxmlformats.org/drawingml/2006/main">
               <a:ext uri="{FF2B5EF4-FFF2-40B4-BE49-F238E27FC236}">
-                <a16:creationId xmlns:a16="http://schemas.microsoft.com/office/drawing/2014/main" id="{A6786B1E-1DE6-49B0-9EED-28B776786130}"/>
+                <a16:creationId xmlns:a16="http://schemas.microsoft.com/office/drawing/2014/main" id="{B5B72BDE-E5CB-4372-BC66-199E14D306AD}"/>
               </a:ext>
             </a:extLst>
           </p:cNvPr>
@@ -6001,7 +6001,7 @@
           <p:cNvPr id="15" name="">
             <a:extLst xmlns:a="http://schemas.openxmlformats.org/drawingml/2006/main">
               <a:ext uri="{FF2B5EF4-FFF2-40B4-BE49-F238E27FC236}">
-                <a16:creationId xmlns:a16="http://schemas.microsoft.com/office/drawing/2014/main" id="{A3CC49A4-28A6-4576-BCFD-989839A5206B}"/>
+                <a16:creationId xmlns:a16="http://schemas.microsoft.com/office/drawing/2014/main" id="{DDB3047F-C7C4-4EBA-9FB4-F54D7FF9F7ED}"/>
               </a:ext>
             </a:extLst>
           </p:cNvPr>
@@ -6058,7 +6058,7 @@
           <p:cNvPr id="16" name="">
             <a:extLst xmlns:a="http://schemas.openxmlformats.org/drawingml/2006/main">
               <a:ext uri="{FF2B5EF4-FFF2-40B4-BE49-F238E27FC236}">
-                <a16:creationId xmlns:a16="http://schemas.microsoft.com/office/drawing/2014/main" id="{23C04396-7A53-423A-AEDF-62E0BB6BD5A6}"/>
+                <a16:creationId xmlns:a16="http://schemas.microsoft.com/office/drawing/2014/main" id="{58C7D983-8843-4C83-A442-D362ADEBC270}"/>
               </a:ext>
             </a:extLst>
           </p:cNvPr>
@@ -6088,7 +6088,7 @@
           <p:cNvPr id="17" name="">
             <a:extLst xmlns:a="http://schemas.openxmlformats.org/drawingml/2006/main">
               <a:ext uri="{FF2B5EF4-FFF2-40B4-BE49-F238E27FC236}">
-                <a16:creationId xmlns:a16="http://schemas.microsoft.com/office/drawing/2014/main" id="{3E3A1E1E-4D48-46F9-881B-904CBD33BFB7}"/>
+                <a16:creationId xmlns:a16="http://schemas.microsoft.com/office/drawing/2014/main" id="{1938AB06-4F88-4C64-BBEC-26A327221C0E}"/>
               </a:ext>
             </a:extLst>
           </p:cNvPr>
@@ -6145,7 +6145,7 @@
           <p:cNvPr id="18" name="">
             <a:extLst xmlns:a="http://schemas.openxmlformats.org/drawingml/2006/main">
               <a:ext uri="{FF2B5EF4-FFF2-40B4-BE49-F238E27FC236}">
-                <a16:creationId xmlns:a16="http://schemas.microsoft.com/office/drawing/2014/main" id="{C8377062-13A6-491A-83C0-705995B21C57}"/>
+                <a16:creationId xmlns:a16="http://schemas.microsoft.com/office/drawing/2014/main" id="{B46755EB-1CAA-43A1-ADB7-BDC4C82BE3EB}"/>
               </a:ext>
             </a:extLst>
           </p:cNvPr>
@@ -6175,7 +6175,7 @@
           <p:cNvPr id="19" name="">
             <a:extLst xmlns:a="http://schemas.openxmlformats.org/drawingml/2006/main">
               <a:ext uri="{FF2B5EF4-FFF2-40B4-BE49-F238E27FC236}">
-                <a16:creationId xmlns:a16="http://schemas.microsoft.com/office/drawing/2014/main" id="{D9E0D5C0-75C4-4AF6-9058-60960DC3847E}"/>
+                <a16:creationId xmlns:a16="http://schemas.microsoft.com/office/drawing/2014/main" id="{76703468-43DA-4BDF-BDE9-F97DB86F5DC2}"/>
               </a:ext>
             </a:extLst>
           </p:cNvPr>
@@ -6232,7 +6232,7 @@
           <p:cNvPr id="20" name="">
             <a:extLst xmlns:a="http://schemas.openxmlformats.org/drawingml/2006/main">
               <a:ext uri="{FF2B5EF4-FFF2-40B4-BE49-F238E27FC236}">
-                <a16:creationId xmlns:a16="http://schemas.microsoft.com/office/drawing/2014/main" id="{CDA9182B-2135-4C35-82E9-5139DD880213}"/>
+                <a16:creationId xmlns:a16="http://schemas.microsoft.com/office/drawing/2014/main" id="{3B8BFBBD-2013-4492-AED2-DBFA6EAA1D78}"/>
               </a:ext>
             </a:extLst>
           </p:cNvPr>
@@ -6262,7 +6262,7 @@
           <p:cNvPr id="21" name="">
             <a:extLst xmlns:a="http://schemas.openxmlformats.org/drawingml/2006/main">
               <a:ext uri="{FF2B5EF4-FFF2-40B4-BE49-F238E27FC236}">
-                <a16:creationId xmlns:a16="http://schemas.microsoft.com/office/drawing/2014/main" id="{F471ABDE-2BF0-4B89-8597-A2CC9D6E1ABB}"/>
+                <a16:creationId xmlns:a16="http://schemas.microsoft.com/office/drawing/2014/main" id="{8F3BBD9B-8E91-426D-889A-A0F158F4331A}"/>
               </a:ext>
             </a:extLst>
           </p:cNvPr>
@@ -6319,7 +6319,7 @@
           <p:cNvPr id="22" name="">
             <a:extLst xmlns:a="http://schemas.openxmlformats.org/drawingml/2006/main">
               <a:ext uri="{FF2B5EF4-FFF2-40B4-BE49-F238E27FC236}">
-                <a16:creationId xmlns:a16="http://schemas.microsoft.com/office/drawing/2014/main" id="{4FE77992-6D8F-4095-B43E-094F1685830D}"/>
+                <a16:creationId xmlns:a16="http://schemas.microsoft.com/office/drawing/2014/main" id="{5F8EBAF6-066F-4957-A0E6-F9F41C652C36}"/>
               </a:ext>
             </a:extLst>
           </p:cNvPr>
@@ -6349,7 +6349,7 @@
           <p:cNvPr id="23" name="">
             <a:extLst xmlns:a="http://schemas.openxmlformats.org/drawingml/2006/main">
               <a:ext uri="{FF2B5EF4-FFF2-40B4-BE49-F238E27FC236}">
-                <a16:creationId xmlns:a16="http://schemas.microsoft.com/office/drawing/2014/main" id="{42040AA8-74D2-4AFB-8883-3C7C60F32127}"/>
+                <a16:creationId xmlns:a16="http://schemas.microsoft.com/office/drawing/2014/main" id="{F9E26DFC-6ABC-473A-B176-B22F32D6419C}"/>
               </a:ext>
             </a:extLst>
           </p:cNvPr>
@@ -6406,7 +6406,7 @@
           <p:cNvPr id="24" name="">
             <a:extLst xmlns:a="http://schemas.openxmlformats.org/drawingml/2006/main">
               <a:ext uri="{FF2B5EF4-FFF2-40B4-BE49-F238E27FC236}">
-                <a16:creationId xmlns:a16="http://schemas.microsoft.com/office/drawing/2014/main" id="{90104D69-B7E6-452E-ACB5-A799C280FD72}"/>
+                <a16:creationId xmlns:a16="http://schemas.microsoft.com/office/drawing/2014/main" id="{A0049A9E-69D3-4C0E-A71D-2CF6E435A334}"/>
               </a:ext>
             </a:extLst>
           </p:cNvPr>
@@ -6436,7 +6436,7 @@
           <p:cNvPr id="25" name="">
             <a:extLst xmlns:a="http://schemas.openxmlformats.org/drawingml/2006/main">
               <a:ext uri="{FF2B5EF4-FFF2-40B4-BE49-F238E27FC236}">
-                <a16:creationId xmlns:a16="http://schemas.microsoft.com/office/drawing/2014/main" id="{B050421A-10EA-4C17-A921-0E4FDE52C368}"/>
+                <a16:creationId xmlns:a16="http://schemas.microsoft.com/office/drawing/2014/main" id="{990059DD-457A-46A3-A089-39C8A3629E20}"/>
               </a:ext>
             </a:extLst>
           </p:cNvPr>
@@ -6493,7 +6493,7 @@
           <p:cNvPr id="26" name="">
             <a:extLst xmlns:a="http://schemas.openxmlformats.org/drawingml/2006/main">
               <a:ext uri="{FF2B5EF4-FFF2-40B4-BE49-F238E27FC236}">
-                <a16:creationId xmlns:a16="http://schemas.microsoft.com/office/drawing/2014/main" id="{B51DDB65-D091-4D45-B6BC-8FC2700B4F5C}"/>
+                <a16:creationId xmlns:a16="http://schemas.microsoft.com/office/drawing/2014/main" id="{0336F22A-E420-4984-ADA5-556C05D25D4C}"/>
               </a:ext>
             </a:extLst>
           </p:cNvPr>
@@ -6523,7 +6523,7 @@
           <p:cNvPr id="27" name="">
             <a:extLst xmlns:a="http://schemas.openxmlformats.org/drawingml/2006/main">
               <a:ext uri="{FF2B5EF4-FFF2-40B4-BE49-F238E27FC236}">
-                <a16:creationId xmlns:a16="http://schemas.microsoft.com/office/drawing/2014/main" id="{E446ED96-A401-424A-9EF6-C287F48284D8}"/>
+                <a16:creationId xmlns:a16="http://schemas.microsoft.com/office/drawing/2014/main" id="{20F9CDC3-68DE-4941-BD28-55E9A3806A7A}"/>
               </a:ext>
             </a:extLst>
           </p:cNvPr>
@@ -6580,7 +6580,7 @@
           <p:cNvPr id="28" name="">
             <a:extLst xmlns:a="http://schemas.openxmlformats.org/drawingml/2006/main">
               <a:ext uri="{FF2B5EF4-FFF2-40B4-BE49-F238E27FC236}">
-                <a16:creationId xmlns:a16="http://schemas.microsoft.com/office/drawing/2014/main" id="{EECF712C-39A8-4856-A355-8EBCEB954F9F}"/>
+                <a16:creationId xmlns:a16="http://schemas.microsoft.com/office/drawing/2014/main" id="{96A62847-7E62-4283-A893-FE42C9B82DD6}"/>
               </a:ext>
             </a:extLst>
           </p:cNvPr>
@@ -6610,7 +6610,7 @@
           <p:cNvPr id="29" name="">
             <a:extLst xmlns:a="http://schemas.openxmlformats.org/drawingml/2006/main">
               <a:ext uri="{FF2B5EF4-FFF2-40B4-BE49-F238E27FC236}">
-                <a16:creationId xmlns:a16="http://schemas.microsoft.com/office/drawing/2014/main" id="{A62534EC-6443-4240-A824-CEF00F3E5512}"/>
+                <a16:creationId xmlns:a16="http://schemas.microsoft.com/office/drawing/2014/main" id="{7884AD2D-6ED2-408B-B1A6-836C94416303}"/>
               </a:ext>
             </a:extLst>
           </p:cNvPr>
@@ -6667,7 +6667,7 @@
           <p:cNvPr id="30" name="">
             <a:extLst xmlns:a="http://schemas.openxmlformats.org/drawingml/2006/main">
               <a:ext uri="{FF2B5EF4-FFF2-40B4-BE49-F238E27FC236}">
-                <a16:creationId xmlns:a16="http://schemas.microsoft.com/office/drawing/2014/main" id="{4059003F-1763-4058-8032-DE676464E904}"/>
+                <a16:creationId xmlns:a16="http://schemas.microsoft.com/office/drawing/2014/main" id="{E3BA1A73-2D14-41B0-8F05-FBC2447D0F05}"/>
               </a:ext>
             </a:extLst>
           </p:cNvPr>
@@ -6697,7 +6697,7 @@
           <p:cNvPr id="31" name="">
             <a:extLst xmlns:a="http://schemas.openxmlformats.org/drawingml/2006/main">
               <a:ext uri="{FF2B5EF4-FFF2-40B4-BE49-F238E27FC236}">
-                <a16:creationId xmlns:a16="http://schemas.microsoft.com/office/drawing/2014/main" id="{FC72983F-67CE-4142-8EA3-6747DC1957D6}"/>
+                <a16:creationId xmlns:a16="http://schemas.microsoft.com/office/drawing/2014/main" id="{187117E2-3C56-421D-AF17-9FE3C20F4FB6}"/>
               </a:ext>
             </a:extLst>
           </p:cNvPr>
@@ -6754,7 +6754,7 @@
           <p:cNvPr id="32" name="">
             <a:extLst xmlns:a="http://schemas.openxmlformats.org/drawingml/2006/main">
               <a:ext uri="{FF2B5EF4-FFF2-40B4-BE49-F238E27FC236}">
-                <a16:creationId xmlns:a16="http://schemas.microsoft.com/office/drawing/2014/main" id="{46D6F8F4-5265-4170-BB1F-5E4C60F65115}"/>
+                <a16:creationId xmlns:a16="http://schemas.microsoft.com/office/drawing/2014/main" id="{049AF0C8-7B3F-4553-97C8-EF07EE61063D}"/>
               </a:ext>
             </a:extLst>
           </p:cNvPr>
@@ -6784,7 +6784,7 @@
           <p:cNvPr id="33" name="">
             <a:extLst xmlns:a="http://schemas.openxmlformats.org/drawingml/2006/main">
               <a:ext uri="{FF2B5EF4-FFF2-40B4-BE49-F238E27FC236}">
-                <a16:creationId xmlns:a16="http://schemas.microsoft.com/office/drawing/2014/main" id="{BDC741FD-A86E-4565-B60D-2770301B2560}"/>
+                <a16:creationId xmlns:a16="http://schemas.microsoft.com/office/drawing/2014/main" id="{5FD748D7-E18F-4B01-B4BD-A07991AE7B50}"/>
               </a:ext>
             </a:extLst>
           </p:cNvPr>
@@ -6841,7 +6841,7 @@
           <p:cNvPr id="34" name="">
             <a:extLst xmlns:a="http://schemas.openxmlformats.org/drawingml/2006/main">
               <a:ext uri="{FF2B5EF4-FFF2-40B4-BE49-F238E27FC236}">
-                <a16:creationId xmlns:a16="http://schemas.microsoft.com/office/drawing/2014/main" id="{80866A47-45BB-4D2D-A40A-BE3C7B8B3852}"/>
+                <a16:creationId xmlns:a16="http://schemas.microsoft.com/office/drawing/2014/main" id="{B896E102-4993-4416-A96C-D34B8B33EDED}"/>
               </a:ext>
             </a:extLst>
           </p:cNvPr>
@@ -6871,7 +6871,7 @@
           <p:cNvPr id="35" name="">
             <a:extLst xmlns:a="http://schemas.openxmlformats.org/drawingml/2006/main">
               <a:ext uri="{FF2B5EF4-FFF2-40B4-BE49-F238E27FC236}">
-                <a16:creationId xmlns:a16="http://schemas.microsoft.com/office/drawing/2014/main" id="{DCD896BE-A8B6-4242-9F4C-4D862250EA47}"/>
+                <a16:creationId xmlns:a16="http://schemas.microsoft.com/office/drawing/2014/main" id="{15B50541-F5A2-4A26-A1E6-F4E52B3BB829}"/>
               </a:ext>
             </a:extLst>
           </p:cNvPr>
@@ -6928,7 +6928,7 @@
           <p:cNvPr id="36" name="">
             <a:extLst xmlns:a="http://schemas.openxmlformats.org/drawingml/2006/main">
               <a:ext uri="{FF2B5EF4-FFF2-40B4-BE49-F238E27FC236}">
-                <a16:creationId xmlns:a16="http://schemas.microsoft.com/office/drawing/2014/main" id="{DF7518A5-7B66-46D0-B685-8D4E55DB49E8}"/>
+                <a16:creationId xmlns:a16="http://schemas.microsoft.com/office/drawing/2014/main" id="{985A4745-FD58-4C15-B6EE-A39C060960CF}"/>
               </a:ext>
             </a:extLst>
           </p:cNvPr>
@@ -6958,7 +6958,7 @@
           <p:cNvPr id="37" name="">
             <a:extLst xmlns:a="http://schemas.openxmlformats.org/drawingml/2006/main">
               <a:ext uri="{FF2B5EF4-FFF2-40B4-BE49-F238E27FC236}">
-                <a16:creationId xmlns:a16="http://schemas.microsoft.com/office/drawing/2014/main" id="{92528004-4CA9-45B5-804C-09FF08FFD73C}"/>
+                <a16:creationId xmlns:a16="http://schemas.microsoft.com/office/drawing/2014/main" id="{CAE9D2CC-D70C-4FFF-BCF8-98642D4BB558}"/>
               </a:ext>
             </a:extLst>
           </p:cNvPr>
@@ -7015,7 +7015,7 @@
           <p:cNvPr id="38" name="">
             <a:extLst xmlns:a="http://schemas.openxmlformats.org/drawingml/2006/main">
               <a:ext uri="{FF2B5EF4-FFF2-40B4-BE49-F238E27FC236}">
-                <a16:creationId xmlns:a16="http://schemas.microsoft.com/office/drawing/2014/main" id="{EDEEC312-97F4-496B-913B-76F602FA48DD}"/>
+                <a16:creationId xmlns:a16="http://schemas.microsoft.com/office/drawing/2014/main" id="{EC8C251E-AFB5-4D79-85D2-31A08CCFD105}"/>
               </a:ext>
             </a:extLst>
           </p:cNvPr>
@@ -7045,7 +7045,7 @@
           <p:cNvPr id="39" name="">
             <a:extLst xmlns:a="http://schemas.openxmlformats.org/drawingml/2006/main">
               <a:ext uri="{FF2B5EF4-FFF2-40B4-BE49-F238E27FC236}">
-                <a16:creationId xmlns:a16="http://schemas.microsoft.com/office/drawing/2014/main" id="{121C88D6-EB64-423A-B219-E0924EB191C1}"/>
+                <a16:creationId xmlns:a16="http://schemas.microsoft.com/office/drawing/2014/main" id="{02A5D8AE-B768-4F72-8887-6A640C2BF3FB}"/>
               </a:ext>
             </a:extLst>
           </p:cNvPr>
@@ -7102,7 +7102,7 @@
           <p:cNvPr id="40" name="">
             <a:extLst xmlns:a="http://schemas.openxmlformats.org/drawingml/2006/main">
               <a:ext uri="{FF2B5EF4-FFF2-40B4-BE49-F238E27FC236}">
-                <a16:creationId xmlns:a16="http://schemas.microsoft.com/office/drawing/2014/main" id="{94D261F3-4439-4FB3-AC1F-8F2FFB3FC452}"/>
+                <a16:creationId xmlns:a16="http://schemas.microsoft.com/office/drawing/2014/main" id="{20716AE0-13C6-47CB-BBDF-610C3AFBE114}"/>
               </a:ext>
             </a:extLst>
           </p:cNvPr>
@@ -7132,7 +7132,7 @@
           <p:cNvPr id="41" name="">
             <a:extLst xmlns:a="http://schemas.openxmlformats.org/drawingml/2006/main">
               <a:ext uri="{FF2B5EF4-FFF2-40B4-BE49-F238E27FC236}">
-                <a16:creationId xmlns:a16="http://schemas.microsoft.com/office/drawing/2014/main" id="{861EE449-9B2D-4651-B2BB-3FB4F049FEBD}"/>
+                <a16:creationId xmlns:a16="http://schemas.microsoft.com/office/drawing/2014/main" id="{BC324835-305F-4437-95B9-40E9423DD9CE}"/>
               </a:ext>
             </a:extLst>
           </p:cNvPr>
@@ -7189,7 +7189,7 @@
           <p:cNvPr id="42" name="">
             <a:extLst xmlns:a="http://schemas.openxmlformats.org/drawingml/2006/main">
               <a:ext uri="{FF2B5EF4-FFF2-40B4-BE49-F238E27FC236}">
-                <a16:creationId xmlns:a16="http://schemas.microsoft.com/office/drawing/2014/main" id="{DEF5CBFC-26DF-4D82-874B-BF9DDF2511F1}"/>
+                <a16:creationId xmlns:a16="http://schemas.microsoft.com/office/drawing/2014/main" id="{E81AFD44-E16A-4209-88B2-1A205DC787C1}"/>
               </a:ext>
             </a:extLst>
           </p:cNvPr>
@@ -7219,7 +7219,7 @@
           <p:cNvPr id="43" name="">
             <a:extLst xmlns:a="http://schemas.openxmlformats.org/drawingml/2006/main">
               <a:ext uri="{FF2B5EF4-FFF2-40B4-BE49-F238E27FC236}">
-                <a16:creationId xmlns:a16="http://schemas.microsoft.com/office/drawing/2014/main" id="{422D315F-5FB3-436A-8789-E57157DF25F3}"/>
+                <a16:creationId xmlns:a16="http://schemas.microsoft.com/office/drawing/2014/main" id="{328B0A83-9BCD-4C1F-98FF-3C6E2259D671}"/>
               </a:ext>
             </a:extLst>
           </p:cNvPr>
@@ -7276,7 +7276,7 @@
           <p:cNvPr id="44" name="">
             <a:extLst xmlns:a="http://schemas.openxmlformats.org/drawingml/2006/main">
               <a:ext uri="{FF2B5EF4-FFF2-40B4-BE49-F238E27FC236}">
-                <a16:creationId xmlns:a16="http://schemas.microsoft.com/office/drawing/2014/main" id="{6EEBEAD1-54CB-4869-BB89-446007A7CA9F}"/>
+                <a16:creationId xmlns:a16="http://schemas.microsoft.com/office/drawing/2014/main" id="{25E0804C-B1ED-481B-92A6-5C449E2263A2}"/>
               </a:ext>
             </a:extLst>
           </p:cNvPr>
@@ -7306,7 +7306,7 @@
           <p:cNvPr id="45" name="">
             <a:extLst xmlns:a="http://schemas.openxmlformats.org/drawingml/2006/main">
               <a:ext uri="{FF2B5EF4-FFF2-40B4-BE49-F238E27FC236}">
-                <a16:creationId xmlns:a16="http://schemas.microsoft.com/office/drawing/2014/main" id="{1B5EBB6D-1BBB-4371-8AC0-825743C5CDAC}"/>
+                <a16:creationId xmlns:a16="http://schemas.microsoft.com/office/drawing/2014/main" id="{5B03E0AC-DC6C-4DFF-886F-132FE3142058}"/>
               </a:ext>
             </a:extLst>
           </p:cNvPr>
@@ -7336,7 +7336,7 @@
           <p:cNvPr id="46" name="">
             <a:extLst xmlns:a="http://schemas.openxmlformats.org/drawingml/2006/main">
               <a:ext uri="{FF2B5EF4-FFF2-40B4-BE49-F238E27FC236}">
-                <a16:creationId xmlns:a16="http://schemas.microsoft.com/office/drawing/2014/main" id="{287BE91A-F87A-4755-8E8E-BF8053A501B0}"/>
+                <a16:creationId xmlns:a16="http://schemas.microsoft.com/office/drawing/2014/main" id="{026AC810-6E8D-4EEF-B3F1-7DB8224AC068}"/>
               </a:ext>
             </a:extLst>
           </p:cNvPr>
@@ -7393,7 +7393,7 @@
           <p:cNvPr id="47" name="">
             <a:extLst xmlns:a="http://schemas.openxmlformats.org/drawingml/2006/main">
               <a:ext uri="{FF2B5EF4-FFF2-40B4-BE49-F238E27FC236}">
-                <a16:creationId xmlns:a16="http://schemas.microsoft.com/office/drawing/2014/main" id="{655EB958-40C1-45D0-B4B3-69BC9159B392}"/>
+                <a16:creationId xmlns:a16="http://schemas.microsoft.com/office/drawing/2014/main" id="{9C243517-0468-4591-B8C7-ADBD4916D077}"/>
               </a:ext>
             </a:extLst>
           </p:cNvPr>
@@ -7423,7 +7423,7 @@
           <p:cNvPr id="48" name="">
             <a:extLst xmlns:a="http://schemas.openxmlformats.org/drawingml/2006/main">
               <a:ext uri="{FF2B5EF4-FFF2-40B4-BE49-F238E27FC236}">
-                <a16:creationId xmlns:a16="http://schemas.microsoft.com/office/drawing/2014/main" id="{D8E24A67-87D2-4079-9F59-94929E4A1859}"/>
+                <a16:creationId xmlns:a16="http://schemas.microsoft.com/office/drawing/2014/main" id="{F100E94F-DC7D-409D-AA7D-690E881329A8}"/>
               </a:ext>
             </a:extLst>
           </p:cNvPr>
@@ -7455,7 +7455,7 @@
           <p:cNvPr id="49" name="">
             <a:extLst xmlns:a="http://schemas.openxmlformats.org/drawingml/2006/main">
               <a:ext uri="{FF2B5EF4-FFF2-40B4-BE49-F238E27FC236}">
-                <a16:creationId xmlns:a16="http://schemas.microsoft.com/office/drawing/2014/main" id="{EC6D36D8-CD05-4BB0-871D-398A5D21E90B}"/>
+                <a16:creationId xmlns:a16="http://schemas.microsoft.com/office/drawing/2014/main" id="{42400BBA-F783-44F3-A986-3C6B5F104D6C}"/>
               </a:ext>
             </a:extLst>
           </p:cNvPr>
@@ -7512,7 +7512,7 @@
           <p:cNvPr id="50" name="">
             <a:extLst xmlns:a="http://schemas.openxmlformats.org/drawingml/2006/main">
               <a:ext uri="{FF2B5EF4-FFF2-40B4-BE49-F238E27FC236}">
-                <a16:creationId xmlns:a16="http://schemas.microsoft.com/office/drawing/2014/main" id="{7C2994AA-C571-4FC6-9B66-34DCB891139F}"/>
+                <a16:creationId xmlns:a16="http://schemas.microsoft.com/office/drawing/2014/main" id="{E19C3005-B07E-4748-AF66-8CD94C3CA0EC}"/>
               </a:ext>
             </a:extLst>
           </p:cNvPr>
@@ -7542,7 +7542,7 @@
           <p:cNvPr id="51" name="">
             <a:extLst xmlns:a="http://schemas.openxmlformats.org/drawingml/2006/main">
               <a:ext uri="{FF2B5EF4-FFF2-40B4-BE49-F238E27FC236}">
-                <a16:creationId xmlns:a16="http://schemas.microsoft.com/office/drawing/2014/main" id="{674012B6-EE72-445E-A19C-C6FF276D9479}"/>
+                <a16:creationId xmlns:a16="http://schemas.microsoft.com/office/drawing/2014/main" id="{F4B13601-4757-4401-9754-0191B200B92A}"/>
               </a:ext>
             </a:extLst>
           </p:cNvPr>
@@ -7574,7 +7574,7 @@
           <p:cNvPr id="52" name="">
             <a:extLst xmlns:a="http://schemas.openxmlformats.org/drawingml/2006/main">
               <a:ext uri="{FF2B5EF4-FFF2-40B4-BE49-F238E27FC236}">
-                <a16:creationId xmlns:a16="http://schemas.microsoft.com/office/drawing/2014/main" id="{C557099D-F623-43B9-BFB5-B76A8A417C51}"/>
+                <a16:creationId xmlns:a16="http://schemas.microsoft.com/office/drawing/2014/main" id="{1120D79B-B0E5-4065-A51D-9364BBD839AC}"/>
               </a:ext>
             </a:extLst>
           </p:cNvPr>
@@ -7631,7 +7631,7 @@
           <p:cNvPr id="53" name="">
             <a:extLst xmlns:a="http://schemas.openxmlformats.org/drawingml/2006/main">
               <a:ext uri="{FF2B5EF4-FFF2-40B4-BE49-F238E27FC236}">
-                <a16:creationId xmlns:a16="http://schemas.microsoft.com/office/drawing/2014/main" id="{F3AC2C11-A5D4-4A49-B376-6F943DBAED8C}"/>
+                <a16:creationId xmlns:a16="http://schemas.microsoft.com/office/drawing/2014/main" id="{BF240D11-BA7B-4BF4-A0D9-9204C1FC77D1}"/>
               </a:ext>
             </a:extLst>
           </p:cNvPr>
@@ -7661,7 +7661,7 @@
           <p:cNvPr id="54" name="">
             <a:extLst xmlns:a="http://schemas.openxmlformats.org/drawingml/2006/main">
               <a:ext uri="{FF2B5EF4-FFF2-40B4-BE49-F238E27FC236}">
-                <a16:creationId xmlns:a16="http://schemas.microsoft.com/office/drawing/2014/main" id="{841A862B-5C17-4D79-BA19-DDA0E29F15A6}"/>
+                <a16:creationId xmlns:a16="http://schemas.microsoft.com/office/drawing/2014/main" id="{EB19A49C-D613-4D2A-9CA9-32513E7EAEC6}"/>
               </a:ext>
             </a:extLst>
           </p:cNvPr>
@@ -7693,7 +7693,7 @@
           <p:cNvPr id="55" name="">
             <a:extLst xmlns:a="http://schemas.openxmlformats.org/drawingml/2006/main">
               <a:ext uri="{FF2B5EF4-FFF2-40B4-BE49-F238E27FC236}">
-                <a16:creationId xmlns:a16="http://schemas.microsoft.com/office/drawing/2014/main" id="{74AA4C08-4A60-446A-80B7-6F7746ACE9B8}"/>
+                <a16:creationId xmlns:a16="http://schemas.microsoft.com/office/drawing/2014/main" id="{060B5376-003A-4FD4-95E9-6B1A5C8093B4}"/>
               </a:ext>
             </a:extLst>
           </p:cNvPr>
@@ -7750,7 +7750,7 @@
           <p:cNvPr id="56" name="">
             <a:extLst xmlns:a="http://schemas.openxmlformats.org/drawingml/2006/main">
               <a:ext uri="{FF2B5EF4-FFF2-40B4-BE49-F238E27FC236}">
-                <a16:creationId xmlns:a16="http://schemas.microsoft.com/office/drawing/2014/main" id="{5C728029-45AA-4A22-AC96-D30D55FCD121}"/>
+                <a16:creationId xmlns:a16="http://schemas.microsoft.com/office/drawing/2014/main" id="{640CB574-0E30-4134-9051-A43261F96FEB}"/>
               </a:ext>
             </a:extLst>
           </p:cNvPr>
@@ -7780,7 +7780,7 @@
           <p:cNvPr id="57" name="">
             <a:extLst xmlns:a="http://schemas.openxmlformats.org/drawingml/2006/main">
               <a:ext uri="{FF2B5EF4-FFF2-40B4-BE49-F238E27FC236}">
-                <a16:creationId xmlns:a16="http://schemas.microsoft.com/office/drawing/2014/main" id="{6D1D2803-21CB-4BFB-AB10-E29CE368A31C}"/>
+                <a16:creationId xmlns:a16="http://schemas.microsoft.com/office/drawing/2014/main" id="{E21318D0-42DF-4403-B1C4-1887FA0FD08D}"/>
               </a:ext>
             </a:extLst>
           </p:cNvPr>
@@ -7812,7 +7812,7 @@
           <p:cNvPr id="58" name="">
             <a:extLst xmlns:a="http://schemas.openxmlformats.org/drawingml/2006/main">
               <a:ext uri="{FF2B5EF4-FFF2-40B4-BE49-F238E27FC236}">
-                <a16:creationId xmlns:a16="http://schemas.microsoft.com/office/drawing/2014/main" id="{9ACEF543-8573-4BD2-B343-AD103164EEE2}"/>
+                <a16:creationId xmlns:a16="http://schemas.microsoft.com/office/drawing/2014/main" id="{86EFB8A4-A169-41AC-B9FE-A1FF88CE3682}"/>
               </a:ext>
             </a:extLst>
           </p:cNvPr>
@@ -7869,7 +7869,7 @@
           <p:cNvPr id="59" name="">
             <a:extLst xmlns:a="http://schemas.openxmlformats.org/drawingml/2006/main">
               <a:ext uri="{FF2B5EF4-FFF2-40B4-BE49-F238E27FC236}">
-                <a16:creationId xmlns:a16="http://schemas.microsoft.com/office/drawing/2014/main" id="{6830AACC-BAAF-4BDC-8F23-187741C73F06}"/>
+                <a16:creationId xmlns:a16="http://schemas.microsoft.com/office/drawing/2014/main" id="{9DE072CD-2A7F-47EA-A029-7CAA38152398}"/>
               </a:ext>
             </a:extLst>
           </p:cNvPr>
@@ -7899,7 +7899,7 @@
           <p:cNvPr id="60" name="">
             <a:extLst xmlns:a="http://schemas.openxmlformats.org/drawingml/2006/main">
               <a:ext uri="{FF2B5EF4-FFF2-40B4-BE49-F238E27FC236}">
-                <a16:creationId xmlns:a16="http://schemas.microsoft.com/office/drawing/2014/main" id="{94B395C5-85BB-4FD9-A71F-18DBD338E19C}"/>
+                <a16:creationId xmlns:a16="http://schemas.microsoft.com/office/drawing/2014/main" id="{F96F7CC0-61AA-4F4B-97F4-6B30AB99E495}"/>
               </a:ext>
             </a:extLst>
           </p:cNvPr>
@@ -7931,7 +7931,7 @@
           <p:cNvPr id="61" name="">
             <a:extLst xmlns:a="http://schemas.openxmlformats.org/drawingml/2006/main">
               <a:ext uri="{FF2B5EF4-FFF2-40B4-BE49-F238E27FC236}">
-                <a16:creationId xmlns:a16="http://schemas.microsoft.com/office/drawing/2014/main" id="{5F082C77-4796-4E86-B2F5-30A392EB3B11}"/>
+                <a16:creationId xmlns:a16="http://schemas.microsoft.com/office/drawing/2014/main" id="{E1D002FE-62E2-4725-BED4-67AE3514D6E9}"/>
               </a:ext>
             </a:extLst>
           </p:cNvPr>
@@ -7988,7 +7988,7 @@
           <p:cNvPr id="62" name="">
             <a:extLst xmlns:a="http://schemas.openxmlformats.org/drawingml/2006/main">
               <a:ext uri="{FF2B5EF4-FFF2-40B4-BE49-F238E27FC236}">
-                <a16:creationId xmlns:a16="http://schemas.microsoft.com/office/drawing/2014/main" id="{6FE1EF0C-8B46-4AC5-BFD7-DAFA4ED1EE94}"/>
+                <a16:creationId xmlns:a16="http://schemas.microsoft.com/office/drawing/2014/main" id="{D2069D7D-2B91-4790-A6C3-A699325A1411}"/>
               </a:ext>
             </a:extLst>
           </p:cNvPr>
@@ -8018,7 +8018,7 @@
           <p:cNvPr id="63" name="">
             <a:extLst xmlns:a="http://schemas.openxmlformats.org/drawingml/2006/main">
               <a:ext uri="{FF2B5EF4-FFF2-40B4-BE49-F238E27FC236}">
-                <a16:creationId xmlns:a16="http://schemas.microsoft.com/office/drawing/2014/main" id="{E6D56195-9D1B-499A-9616-396361640FD9}"/>
+                <a16:creationId xmlns:a16="http://schemas.microsoft.com/office/drawing/2014/main" id="{B3AC0BF9-6865-4011-907E-E2C9F7654076}"/>
               </a:ext>
             </a:extLst>
           </p:cNvPr>
@@ -8050,7 +8050,7 @@
           <p:cNvPr id="64" name="">
             <a:extLst xmlns:a="http://schemas.openxmlformats.org/drawingml/2006/main">
               <a:ext uri="{FF2B5EF4-FFF2-40B4-BE49-F238E27FC236}">
-                <a16:creationId xmlns:a16="http://schemas.microsoft.com/office/drawing/2014/main" id="{247E24F9-34BD-4F1C-91AD-996227580E3C}"/>
+                <a16:creationId xmlns:a16="http://schemas.microsoft.com/office/drawing/2014/main" id="{A08826E6-5602-47A2-B124-EBDCFA12EBD4}"/>
               </a:ext>
             </a:extLst>
           </p:cNvPr>
@@ -8107,7 +8107,7 @@
           <p:cNvPr id="65" name="">
             <a:extLst xmlns:a="http://schemas.openxmlformats.org/drawingml/2006/main">
               <a:ext uri="{FF2B5EF4-FFF2-40B4-BE49-F238E27FC236}">
-                <a16:creationId xmlns:a16="http://schemas.microsoft.com/office/drawing/2014/main" id="{76791541-C20D-41CB-BFA7-DE061D2EF68D}"/>
+                <a16:creationId xmlns:a16="http://schemas.microsoft.com/office/drawing/2014/main" id="{E10FB7F7-34F4-4D7C-9897-559C85D30196}"/>
               </a:ext>
             </a:extLst>
           </p:cNvPr>
@@ -8137,7 +8137,7 @@
           <p:cNvPr id="66" name="">
             <a:extLst xmlns:a="http://schemas.openxmlformats.org/drawingml/2006/main">
               <a:ext uri="{FF2B5EF4-FFF2-40B4-BE49-F238E27FC236}">
-                <a16:creationId xmlns:a16="http://schemas.microsoft.com/office/drawing/2014/main" id="{8DC6A7A7-DE64-4818-A250-4A43698844B7}"/>
+                <a16:creationId xmlns:a16="http://schemas.microsoft.com/office/drawing/2014/main" id="{21903D5A-A204-4968-9195-5D4214F15163}"/>
               </a:ext>
             </a:extLst>
           </p:cNvPr>
@@ -8169,7 +8169,7 @@
           <p:cNvPr id="67" name="">
             <a:extLst xmlns:a="http://schemas.openxmlformats.org/drawingml/2006/main">
               <a:ext uri="{FF2B5EF4-FFF2-40B4-BE49-F238E27FC236}">
-                <a16:creationId xmlns:a16="http://schemas.microsoft.com/office/drawing/2014/main" id="{41CB9DFB-C53A-4142-BB61-9F5ED0924C59}"/>
+                <a16:creationId xmlns:a16="http://schemas.microsoft.com/office/drawing/2014/main" id="{50AE61DA-99B1-4791-9C12-06A7808B9CCF}"/>
               </a:ext>
             </a:extLst>
           </p:cNvPr>
@@ -8226,7 +8226,7 @@
           <p:cNvPr id="68" name="">
             <a:extLst xmlns:a="http://schemas.openxmlformats.org/drawingml/2006/main">
               <a:ext uri="{FF2B5EF4-FFF2-40B4-BE49-F238E27FC236}">
-                <a16:creationId xmlns:a16="http://schemas.microsoft.com/office/drawing/2014/main" id="{85013FAB-CED4-45A8-BA2D-3C58F80C9045}"/>
+                <a16:creationId xmlns:a16="http://schemas.microsoft.com/office/drawing/2014/main" id="{325B173F-0DAB-4E7C-A5D3-E8773BDD2D09}"/>
               </a:ext>
             </a:extLst>
           </p:cNvPr>
@@ -8256,7 +8256,7 @@
           <p:cNvPr id="69" name="">
             <a:extLst xmlns:a="http://schemas.openxmlformats.org/drawingml/2006/main">
               <a:ext uri="{FF2B5EF4-FFF2-40B4-BE49-F238E27FC236}">
-                <a16:creationId xmlns:a16="http://schemas.microsoft.com/office/drawing/2014/main" id="{A909F765-4436-4B53-AC75-701365F48EC5}"/>
+                <a16:creationId xmlns:a16="http://schemas.microsoft.com/office/drawing/2014/main" id="{72B1CE5A-8CE7-422A-8E56-C50F5128C2FE}"/>
               </a:ext>
             </a:extLst>
           </p:cNvPr>
@@ -8288,7 +8288,7 @@
           <p:cNvPr id="70" name="">
             <a:extLst xmlns:a="http://schemas.openxmlformats.org/drawingml/2006/main">
               <a:ext uri="{FF2B5EF4-FFF2-40B4-BE49-F238E27FC236}">
-                <a16:creationId xmlns:a16="http://schemas.microsoft.com/office/drawing/2014/main" id="{5202266D-ECB5-4D59-9FDC-59466F589BF5}"/>
+                <a16:creationId xmlns:a16="http://schemas.microsoft.com/office/drawing/2014/main" id="{FB3E7B8F-A18B-4555-9631-8B1B92894698}"/>
               </a:ext>
             </a:extLst>
           </p:cNvPr>
@@ -8345,7 +8345,7 @@
           <p:cNvPr id="71" name="">
             <a:extLst xmlns:a="http://schemas.openxmlformats.org/drawingml/2006/main">
               <a:ext uri="{FF2B5EF4-FFF2-40B4-BE49-F238E27FC236}">
-                <a16:creationId xmlns:a16="http://schemas.microsoft.com/office/drawing/2014/main" id="{629BD3AC-2CE1-432A-9D8E-183B1FBE8D75}"/>
+                <a16:creationId xmlns:a16="http://schemas.microsoft.com/office/drawing/2014/main" id="{28120965-C78A-4DD8-B5C4-BBB2E9593A30}"/>
               </a:ext>
             </a:extLst>
           </p:cNvPr>
@@ -8375,19 +8375,19 @@
           <p:cNvPr id="72" name="">
             <a:extLst xmlns:a="http://schemas.openxmlformats.org/drawingml/2006/main">
               <a:ext uri="{FF2B5EF4-FFF2-40B4-BE49-F238E27FC236}">
-                <a16:creationId xmlns:a16="http://schemas.microsoft.com/office/drawing/2014/main" id="{E3E7FCC8-BB49-43B0-AB42-643CD5197771}"/>
-              </a:ext>
-            </a:extLst>
-          </p:cNvPr>
-          <p:cNvSpPr>
-            <a:spLocks xmlns:a="http://schemas.openxmlformats.org/drawingml/2006/main" noGrp="1"/>
-          </p:cNvSpPr>
-          <p:nvPr/>
-        </p:nvSpPr>
-        <p:spPr>
-          <a:xfrm xmlns:a="http://schemas.openxmlformats.org/drawingml/2006/main">
-            <a:off x="8534400" y="4105275"/>
-            <a:ext cx="390525" cy="200025"/>
+                <a16:creationId xmlns:a16="http://schemas.microsoft.com/office/drawing/2014/main" id="{AF7442ED-F38C-4732-936E-50D8CD37C46C}"/>
+              </a:ext>
+            </a:extLst>
+          </p:cNvPr>
+          <p:cNvSpPr>
+            <a:spLocks xmlns:a="http://schemas.openxmlformats.org/drawingml/2006/main" noGrp="1"/>
+          </p:cNvSpPr>
+          <p:nvPr/>
+        </p:nvSpPr>
+        <p:spPr>
+          <a:xfrm xmlns:a="http://schemas.openxmlformats.org/drawingml/2006/main">
+            <a:off x="8086725" y="4105275"/>
+            <a:ext cx="838200" cy="200025"/>
           </a:xfrm>
           <a:prstGeom xmlns:a="http://schemas.openxmlformats.org/drawingml/2006/main" prst="rect">
             <a:avLst/>
@@ -8407,7 +8407,7 @@
           <p:cNvPr id="73" name="">
             <a:extLst xmlns:a="http://schemas.openxmlformats.org/drawingml/2006/main">
               <a:ext uri="{FF2B5EF4-FFF2-40B4-BE49-F238E27FC236}">
-                <a16:creationId xmlns:a16="http://schemas.microsoft.com/office/drawing/2014/main" id="{F9393F8B-099D-469C-B513-607323613D09}"/>
+                <a16:creationId xmlns:a16="http://schemas.microsoft.com/office/drawing/2014/main" id="{65A9777E-A58C-46A6-A362-59090070CFC0}"/>
               </a:ext>
             </a:extLst>
           </p:cNvPr>
@@ -8464,7 +8464,7 @@
           <p:cNvPr id="74" name="">
             <a:extLst xmlns:a="http://schemas.openxmlformats.org/drawingml/2006/main">
               <a:ext uri="{FF2B5EF4-FFF2-40B4-BE49-F238E27FC236}">
-                <a16:creationId xmlns:a16="http://schemas.microsoft.com/office/drawing/2014/main" id="{5098DEEB-4B06-4950-A46F-D3257EFFDA81}"/>
+                <a16:creationId xmlns:a16="http://schemas.microsoft.com/office/drawing/2014/main" id="{7E407DE1-17C2-4051-AD26-9A6C7D702AAE}"/>
               </a:ext>
             </a:extLst>
           </p:cNvPr>
@@ -8494,7 +8494,7 @@
           <p:cNvPr id="75" name="">
             <a:extLst xmlns:a="http://schemas.openxmlformats.org/drawingml/2006/main">
               <a:ext uri="{FF2B5EF4-FFF2-40B4-BE49-F238E27FC236}">
-                <a16:creationId xmlns:a16="http://schemas.microsoft.com/office/drawing/2014/main" id="{EB6D7784-8E05-4F81-9607-EBD521A726AC}"/>
+                <a16:creationId xmlns:a16="http://schemas.microsoft.com/office/drawing/2014/main" id="{CD154E45-2495-4ACC-8F26-E43DF40E4274}"/>
               </a:ext>
             </a:extLst>
           </p:cNvPr>
@@ -8526,7 +8526,7 @@
           <p:cNvPr id="76" name="">
             <a:extLst xmlns:a="http://schemas.openxmlformats.org/drawingml/2006/main">
               <a:ext uri="{FF2B5EF4-FFF2-40B4-BE49-F238E27FC236}">
-                <a16:creationId xmlns:a16="http://schemas.microsoft.com/office/drawing/2014/main" id="{B25F8B6B-8227-43E6-A80B-85EE8D4A1C44}"/>
+                <a16:creationId xmlns:a16="http://schemas.microsoft.com/office/drawing/2014/main" id="{9A9F2363-1224-4F71-A3BE-8C1AF92B87A8}"/>
               </a:ext>
             </a:extLst>
           </p:cNvPr>
@@ -8583,7 +8583,7 @@
           <p:cNvPr id="77" name="">
             <a:extLst xmlns:a="http://schemas.openxmlformats.org/drawingml/2006/main">
               <a:ext uri="{FF2B5EF4-FFF2-40B4-BE49-F238E27FC236}">
-                <a16:creationId xmlns:a16="http://schemas.microsoft.com/office/drawing/2014/main" id="{8BCB1078-B0E3-44CA-9F4F-C0DAC909542D}"/>
+                <a16:creationId xmlns:a16="http://schemas.microsoft.com/office/drawing/2014/main" id="{9B58C073-8088-4DED-8F51-64A4A26DCA70}"/>
               </a:ext>
             </a:extLst>
           </p:cNvPr>
@@ -8613,7 +8613,7 @@
           <p:cNvPr id="78" name="">
             <a:extLst xmlns:a="http://schemas.openxmlformats.org/drawingml/2006/main">
               <a:ext uri="{FF2B5EF4-FFF2-40B4-BE49-F238E27FC236}">
-                <a16:creationId xmlns:a16="http://schemas.microsoft.com/office/drawing/2014/main" id="{A4675473-B7DE-4791-A69D-5414AA4D902C}"/>
+                <a16:creationId xmlns:a16="http://schemas.microsoft.com/office/drawing/2014/main" id="{4E472618-CADD-469B-AC85-2C71273C6A86}"/>
               </a:ext>
             </a:extLst>
           </p:cNvPr>
@@ -8645,7 +8645,7 @@
           <p:cNvPr id="79" name="">
             <a:extLst xmlns:a="http://schemas.openxmlformats.org/drawingml/2006/main">
               <a:ext uri="{FF2B5EF4-FFF2-40B4-BE49-F238E27FC236}">
-                <a16:creationId xmlns:a16="http://schemas.microsoft.com/office/drawing/2014/main" id="{97F60435-43B8-4549-A5C1-33284BB07290}"/>
+                <a16:creationId xmlns:a16="http://schemas.microsoft.com/office/drawing/2014/main" id="{D184678F-4604-4132-B7DF-8AEAF9CDF3D8}"/>
               </a:ext>
             </a:extLst>
           </p:cNvPr>
@@ -8702,7 +8702,7 @@
           <p:cNvPr id="80" name="">
             <a:extLst xmlns:a="http://schemas.openxmlformats.org/drawingml/2006/main">
               <a:ext uri="{FF2B5EF4-FFF2-40B4-BE49-F238E27FC236}">
-                <a16:creationId xmlns:a16="http://schemas.microsoft.com/office/drawing/2014/main" id="{DDE0CB34-5F1E-4A18-B03A-A38F16837D22}"/>
+                <a16:creationId xmlns:a16="http://schemas.microsoft.com/office/drawing/2014/main" id="{BEC05A84-C6B7-4880-AE15-ADE57FD28380}"/>
               </a:ext>
             </a:extLst>
           </p:cNvPr>
@@ -8732,7 +8732,7 @@
           <p:cNvPr id="81" name="">
             <a:extLst xmlns:a="http://schemas.openxmlformats.org/drawingml/2006/main">
               <a:ext uri="{FF2B5EF4-FFF2-40B4-BE49-F238E27FC236}">
-                <a16:creationId xmlns:a16="http://schemas.microsoft.com/office/drawing/2014/main" id="{C4CB9F6C-DE3D-422A-BF2E-6FFA953EC848}"/>
+                <a16:creationId xmlns:a16="http://schemas.microsoft.com/office/drawing/2014/main" id="{A6BE07E5-243D-4B23-8C73-8463DA6F45AE}"/>
               </a:ext>
             </a:extLst>
           </p:cNvPr>
@@ -8764,7 +8764,7 @@
           <p:cNvPr id="82" name="">
             <a:extLst xmlns:a="http://schemas.openxmlformats.org/drawingml/2006/main">
               <a:ext uri="{FF2B5EF4-FFF2-40B4-BE49-F238E27FC236}">
-                <a16:creationId xmlns:a16="http://schemas.microsoft.com/office/drawing/2014/main" id="{B7080D66-ADFC-480B-B2FF-089BD33B599A}"/>
+                <a16:creationId xmlns:a16="http://schemas.microsoft.com/office/drawing/2014/main" id="{4F2B74B0-3464-4F01-B9E9-78B9FB37AB9E}"/>
               </a:ext>
             </a:extLst>
           </p:cNvPr>
@@ -8821,7 +8821,7 @@
           <p:cNvPr id="83" name="">
             <a:extLst xmlns:a="http://schemas.openxmlformats.org/drawingml/2006/main">
               <a:ext uri="{FF2B5EF4-FFF2-40B4-BE49-F238E27FC236}">
-                <a16:creationId xmlns:a16="http://schemas.microsoft.com/office/drawing/2014/main" id="{B1B7BBD1-D587-4A18-98F7-2449DA583A37}"/>
+                <a16:creationId xmlns:a16="http://schemas.microsoft.com/office/drawing/2014/main" id="{A7AC6C3D-2683-4EF2-96A0-415A9C04EDBE}"/>
               </a:ext>
             </a:extLst>
           </p:cNvPr>
@@ -8851,7 +8851,7 @@
           <p:cNvPr id="84" name="">
             <a:extLst xmlns:a="http://schemas.openxmlformats.org/drawingml/2006/main">
               <a:ext uri="{FF2B5EF4-FFF2-40B4-BE49-F238E27FC236}">
-                <a16:creationId xmlns:a16="http://schemas.microsoft.com/office/drawing/2014/main" id="{6687ED95-5F03-4C21-A14C-015216929FAE}"/>
+                <a16:creationId xmlns:a16="http://schemas.microsoft.com/office/drawing/2014/main" id="{D46FCD4C-B1DA-407E-B442-C335DDEE946B}"/>
               </a:ext>
             </a:extLst>
           </p:cNvPr>
@@ -8883,7 +8883,7 @@
           <p:cNvPr id="85" name="">
             <a:extLst xmlns:a="http://schemas.openxmlformats.org/drawingml/2006/main">
               <a:ext uri="{FF2B5EF4-FFF2-40B4-BE49-F238E27FC236}">
-                <a16:creationId xmlns:a16="http://schemas.microsoft.com/office/drawing/2014/main" id="{11D7E0EF-9436-4FBE-BE83-F137DC7348AF}"/>
+                <a16:creationId xmlns:a16="http://schemas.microsoft.com/office/drawing/2014/main" id="{64C134FC-1D15-47E8-A4E2-063850FA0722}"/>
               </a:ext>
             </a:extLst>
           </p:cNvPr>
@@ -8915,19 +8915,19 @@
           <p:cNvPr id="86" name="">
             <a:extLst xmlns:a="http://schemas.openxmlformats.org/drawingml/2006/main">
               <a:ext uri="{FF2B5EF4-FFF2-40B4-BE49-F238E27FC236}">
-                <a16:creationId xmlns:a16="http://schemas.microsoft.com/office/drawing/2014/main" id="{0B841306-8F5D-404F-A471-D76C2FC3B961}"/>
-              </a:ext>
-            </a:extLst>
-          </p:cNvPr>
-          <p:cNvSpPr>
-            <a:spLocks xmlns:a="http://schemas.openxmlformats.org/drawingml/2006/main" noGrp="1"/>
-          </p:cNvSpPr>
-          <p:nvPr/>
-        </p:nvSpPr>
-        <p:spPr>
-          <a:xfrm xmlns:a="http://schemas.openxmlformats.org/drawingml/2006/main">
-            <a:off x="2586038" y="6029325"/>
-            <a:ext cx="647700" cy="190500"/>
+                <a16:creationId xmlns:a16="http://schemas.microsoft.com/office/drawing/2014/main" id="{77A4D4E8-DDCE-46E8-A2AA-EB5CFDA00CD3}"/>
+              </a:ext>
+            </a:extLst>
+          </p:cNvPr>
+          <p:cNvSpPr>
+            <a:spLocks xmlns:a="http://schemas.openxmlformats.org/drawingml/2006/main" noGrp="1"/>
+          </p:cNvSpPr>
+          <p:nvPr/>
+        </p:nvSpPr>
+        <p:spPr>
+          <a:xfrm xmlns:a="http://schemas.openxmlformats.org/drawingml/2006/main">
+            <a:off x="2509838" y="6029325"/>
+            <a:ext cx="800100" cy="190500"/>
           </a:xfrm>
           <a:prstGeom xmlns:a="http://schemas.openxmlformats.org/drawingml/2006/main" prst="rect">
             <a:avLst/>
@@ -8972,7 +8972,7 @@
           <p:cNvPr id="87" name="">
             <a:extLst xmlns:a="http://schemas.openxmlformats.org/drawingml/2006/main">
               <a:ext uri="{FF2B5EF4-FFF2-40B4-BE49-F238E27FC236}">
-                <a16:creationId xmlns:a16="http://schemas.microsoft.com/office/drawing/2014/main" id="{90796247-50C6-474F-955F-65ED3300D37D}"/>
+                <a16:creationId xmlns:a16="http://schemas.microsoft.com/office/drawing/2014/main" id="{7BE86DFB-39B9-4863-8096-E0AB0AD797EA}"/>
               </a:ext>
             </a:extLst>
           </p:cNvPr>
@@ -9004,19 +9004,19 @@
           <p:cNvPr id="88" name="">
             <a:extLst xmlns:a="http://schemas.openxmlformats.org/drawingml/2006/main">
               <a:ext uri="{FF2B5EF4-FFF2-40B4-BE49-F238E27FC236}">
-                <a16:creationId xmlns:a16="http://schemas.microsoft.com/office/drawing/2014/main" id="{10169023-5EFA-4DE9-BE19-33A8BC754039}"/>
-              </a:ext>
-            </a:extLst>
-          </p:cNvPr>
-          <p:cNvSpPr>
-            <a:spLocks xmlns:a="http://schemas.openxmlformats.org/drawingml/2006/main" noGrp="1"/>
-          </p:cNvSpPr>
-          <p:nvPr/>
-        </p:nvSpPr>
-        <p:spPr>
-          <a:xfrm xmlns:a="http://schemas.openxmlformats.org/drawingml/2006/main">
-            <a:off x="4376738" y="6029325"/>
-            <a:ext cx="647700" cy="190500"/>
+                <a16:creationId xmlns:a16="http://schemas.microsoft.com/office/drawing/2014/main" id="{9AA84E2B-EBCD-4FB4-BB03-5978B5F364A1}"/>
+              </a:ext>
+            </a:extLst>
+          </p:cNvPr>
+          <p:cNvSpPr>
+            <a:spLocks xmlns:a="http://schemas.openxmlformats.org/drawingml/2006/main" noGrp="1"/>
+          </p:cNvSpPr>
+          <p:nvPr/>
+        </p:nvSpPr>
+        <p:spPr>
+          <a:xfrm xmlns:a="http://schemas.openxmlformats.org/drawingml/2006/main">
+            <a:off x="4300538" y="6029325"/>
+            <a:ext cx="800100" cy="190500"/>
           </a:xfrm>
           <a:prstGeom xmlns:a="http://schemas.openxmlformats.org/drawingml/2006/main" prst="rect">
             <a:avLst/>
@@ -9061,7 +9061,7 @@
           <p:cNvPr id="89" name="">
             <a:extLst xmlns:a="http://schemas.openxmlformats.org/drawingml/2006/main">
               <a:ext uri="{FF2B5EF4-FFF2-40B4-BE49-F238E27FC236}">
-                <a16:creationId xmlns:a16="http://schemas.microsoft.com/office/drawing/2014/main" id="{069DAA25-E017-41C4-A5B0-507AF03BC45C}"/>
+                <a16:creationId xmlns:a16="http://schemas.microsoft.com/office/drawing/2014/main" id="{889052D0-ED7B-4BB1-B9D7-A461B37FC5F9}"/>
               </a:ext>
             </a:extLst>
           </p:cNvPr>
@@ -9093,19 +9093,19 @@
           <p:cNvPr id="90" name="">
             <a:extLst xmlns:a="http://schemas.openxmlformats.org/drawingml/2006/main">
               <a:ext uri="{FF2B5EF4-FFF2-40B4-BE49-F238E27FC236}">
-                <a16:creationId xmlns:a16="http://schemas.microsoft.com/office/drawing/2014/main" id="{102FF0D5-10E6-4EA8-AEBC-2C7E1A230AFB}"/>
-              </a:ext>
-            </a:extLst>
-          </p:cNvPr>
-          <p:cNvSpPr>
-            <a:spLocks xmlns:a="http://schemas.openxmlformats.org/drawingml/2006/main" noGrp="1"/>
-          </p:cNvSpPr>
-          <p:nvPr/>
-        </p:nvSpPr>
-        <p:spPr>
-          <a:xfrm xmlns:a="http://schemas.openxmlformats.org/drawingml/2006/main">
-            <a:off x="8853488" y="6029325"/>
-            <a:ext cx="647700" cy="190500"/>
+                <a16:creationId xmlns:a16="http://schemas.microsoft.com/office/drawing/2014/main" id="{05E4CE50-7B36-461C-AF99-80560E023C81}"/>
+              </a:ext>
+            </a:extLst>
+          </p:cNvPr>
+          <p:cNvSpPr>
+            <a:spLocks xmlns:a="http://schemas.openxmlformats.org/drawingml/2006/main" noGrp="1"/>
+          </p:cNvSpPr>
+          <p:nvPr/>
+        </p:nvSpPr>
+        <p:spPr>
+          <a:xfrm xmlns:a="http://schemas.openxmlformats.org/drawingml/2006/main">
+            <a:off x="8777288" y="6029325"/>
+            <a:ext cx="800100" cy="190500"/>
           </a:xfrm>
           <a:prstGeom xmlns:a="http://schemas.openxmlformats.org/drawingml/2006/main" prst="rect">
             <a:avLst/>
@@ -9150,7 +9150,7 @@
           <p:cNvPr id="91" name="">
             <a:extLst xmlns:a="http://schemas.openxmlformats.org/drawingml/2006/main">
               <a:ext uri="{FF2B5EF4-FFF2-40B4-BE49-F238E27FC236}">
-                <a16:creationId xmlns:a16="http://schemas.microsoft.com/office/drawing/2014/main" id="{F552F51E-EB3D-4A61-B543-0450E77A4C0E}"/>
+                <a16:creationId xmlns:a16="http://schemas.microsoft.com/office/drawing/2014/main" id="{2E8C2F5A-A2B6-4BAD-8496-995171932C68}"/>
               </a:ext>
             </a:extLst>
           </p:cNvPr>
@@ -9182,19 +9182,19 @@
           <p:cNvPr id="92" name="">
             <a:extLst xmlns:a="http://schemas.openxmlformats.org/drawingml/2006/main">
               <a:ext uri="{FF2B5EF4-FFF2-40B4-BE49-F238E27FC236}">
-                <a16:creationId xmlns:a16="http://schemas.microsoft.com/office/drawing/2014/main" id="{CAEB4F5E-3C58-46EB-9A6A-0042C3EC4F6E}"/>
-              </a:ext>
-            </a:extLst>
-          </p:cNvPr>
-          <p:cNvSpPr>
-            <a:spLocks xmlns:a="http://schemas.openxmlformats.org/drawingml/2006/main" noGrp="1"/>
-          </p:cNvSpPr>
-          <p:nvPr/>
-        </p:nvSpPr>
-        <p:spPr>
-          <a:xfrm xmlns:a="http://schemas.openxmlformats.org/drawingml/2006/main">
-            <a:off x="10644188" y="6029325"/>
-            <a:ext cx="647700" cy="190500"/>
+                <a16:creationId xmlns:a16="http://schemas.microsoft.com/office/drawing/2014/main" id="{A3048D70-507C-4443-A70F-1475EB8A0BCF}"/>
+              </a:ext>
+            </a:extLst>
+          </p:cNvPr>
+          <p:cNvSpPr>
+            <a:spLocks xmlns:a="http://schemas.openxmlformats.org/drawingml/2006/main" noGrp="1"/>
+          </p:cNvSpPr>
+          <p:nvPr/>
+        </p:nvSpPr>
+        <p:spPr>
+          <a:xfrm xmlns:a="http://schemas.openxmlformats.org/drawingml/2006/main">
+            <a:off x="10567988" y="6029325"/>
+            <a:ext cx="800100" cy="190500"/>
           </a:xfrm>
           <a:prstGeom xmlns:a="http://schemas.openxmlformats.org/drawingml/2006/main" prst="rect">
             <a:avLst/>
@@ -9229,7 +9229,7 @@
                 <a:ea typeface="Microsoft YaHei"/>
                 <a:cs typeface="Microsoft YaHei"/>
               </a:rPr>
-              <a:t>M4/M5</a:t>
+              <a:t>M4→M5</a:t>
             </a:r>
           </a:p>
         </p:txBody>
@@ -9239,7 +9239,7 @@
           <p:cNvPr id="93" name="">
             <a:extLst xmlns:a="http://schemas.openxmlformats.org/drawingml/2006/main">
               <a:ext uri="{FF2B5EF4-FFF2-40B4-BE49-F238E27FC236}">
-                <a16:creationId xmlns:a16="http://schemas.microsoft.com/office/drawing/2014/main" id="{B4E8662F-D4A3-4CB8-BCC4-092346F49BCB}"/>
+                <a16:creationId xmlns:a16="http://schemas.microsoft.com/office/drawing/2014/main" id="{4CC0542A-FA58-4788-ABC8-CC41836E7C54}"/>
               </a:ext>
             </a:extLst>
           </p:cNvPr>
@@ -9294,7 +9294,7 @@
     </p:spTree>
     <p:extLst>
       <p:ext uri="{BB962C8B-B14F-4D97-AF65-F5344CB8AC3E}">
-        <p14:creationId xmlns:p14="http://schemas.microsoft.com/office/powerpoint/2010/main" val="1325861450"/>
+        <p14:creationId xmlns:p14="http://schemas.microsoft.com/office/powerpoint/2010/main" val="594575371"/>
       </p:ext>
     </p:extLst>
   </p:cSld>
@@ -9325,7 +9325,7 @@
           <p:cNvPr id="23" name="">
             <a:extLst xmlns:a="http://schemas.openxmlformats.org/drawingml/2006/main">
               <a:ext uri="{FF2B5EF4-FFF2-40B4-BE49-F238E27FC236}">
-                <a16:creationId xmlns:a16="http://schemas.microsoft.com/office/drawing/2014/main" id="{86408852-5689-4C33-878A-E69F47C30E84}"/>
+                <a16:creationId xmlns:a16="http://schemas.microsoft.com/office/drawing/2014/main" id="{0109DB38-D52A-4205-8551-3232C51D7EE2}"/>
               </a:ext>
             </a:extLst>
           </p:cNvPr>
@@ -9382,7 +9382,7 @@
           <p:cNvPr id="2" name="">
             <a:extLst xmlns:a="http://schemas.openxmlformats.org/drawingml/2006/main">
               <a:ext uri="{FF2B5EF4-FFF2-40B4-BE49-F238E27FC236}">
-                <a16:creationId xmlns:a16="http://schemas.microsoft.com/office/drawing/2014/main" id="{C6B0F448-FD64-40DD-BEEB-077F8A6356BE}"/>
+                <a16:creationId xmlns:a16="http://schemas.microsoft.com/office/drawing/2014/main" id="{CE7FB27F-88CE-4B48-A71A-9911BBDF7D49}"/>
               </a:ext>
             </a:extLst>
           </p:cNvPr>
@@ -9439,7 +9439,7 @@
           <p:cNvPr id="3" name="">
             <a:extLst xmlns:a="http://schemas.openxmlformats.org/drawingml/2006/main">
               <a:ext uri="{FF2B5EF4-FFF2-40B4-BE49-F238E27FC236}">
-                <a16:creationId xmlns:a16="http://schemas.microsoft.com/office/drawing/2014/main" id="{2F2D2B34-4EA3-4465-AACC-FA42A23303B8}"/>
+                <a16:creationId xmlns:a16="http://schemas.microsoft.com/office/drawing/2014/main" id="{FF950C5E-A8F3-4D99-924E-DB5D7ACA341E}"/>
               </a:ext>
             </a:extLst>
           </p:cNvPr>
@@ -9469,7 +9469,7 @@
           <p:cNvPr id="4" name="">
             <a:extLst xmlns:a="http://schemas.openxmlformats.org/drawingml/2006/main">
               <a:ext uri="{FF2B5EF4-FFF2-40B4-BE49-F238E27FC236}">
-                <a16:creationId xmlns:a16="http://schemas.microsoft.com/office/drawing/2014/main" id="{D94C8080-6BC5-4646-948A-825AE753A7D1}"/>
+                <a16:creationId xmlns:a16="http://schemas.microsoft.com/office/drawing/2014/main" id="{0EA101FF-AC9D-4E85-95DA-79613C087807}"/>
               </a:ext>
             </a:extLst>
           </p:cNvPr>
@@ -9532,7 +9532,7 @@
           <p:cNvPr id="5" name="">
             <a:extLst xmlns:a="http://schemas.openxmlformats.org/drawingml/2006/main">
               <a:ext uri="{FF2B5EF4-FFF2-40B4-BE49-F238E27FC236}">
-                <a16:creationId xmlns:a16="http://schemas.microsoft.com/office/drawing/2014/main" id="{8B2BF757-A3F7-4AFB-9773-AB4E5C510994}"/>
+                <a16:creationId xmlns:a16="http://schemas.microsoft.com/office/drawing/2014/main" id="{A9F6D9DD-B4CF-4042-87CF-83B0417AEA16}"/>
               </a:ext>
             </a:extLst>
           </p:cNvPr>
@@ -9608,7 +9608,7 @@
                 <a:ea typeface="Microsoft YaHei"/>
                 <a:cs typeface="Microsoft YaHei"/>
               </a:rPr>
-              <a:t>阶段评审与交付组织</a:t>
+              <a:t>阶段评审、交付与质保组织</a:t>
             </a:r>
           </a:p>
           <a:p xmlns:a="http://schemas.openxmlformats.org/drawingml/2006/main">
@@ -9641,7 +9641,7 @@
           <p:cNvPr id="6" name="">
             <a:extLst xmlns:a="http://schemas.openxmlformats.org/drawingml/2006/main">
               <a:ext uri="{FF2B5EF4-FFF2-40B4-BE49-F238E27FC236}">
-                <a16:creationId xmlns:a16="http://schemas.microsoft.com/office/drawing/2014/main" id="{98E7DC6F-B7BF-4FE9-B24B-2096AABFE242}"/>
+                <a16:creationId xmlns:a16="http://schemas.microsoft.com/office/drawing/2014/main" id="{370DE417-0968-4A79-B6CE-8AB6687D24EB}"/>
               </a:ext>
             </a:extLst>
           </p:cNvPr>
@@ -9704,7 +9704,7 @@
           <p:cNvPr id="7" name="">
             <a:extLst xmlns:a="http://schemas.openxmlformats.org/drawingml/2006/main">
               <a:ext uri="{FF2B5EF4-FFF2-40B4-BE49-F238E27FC236}">
-                <a16:creationId xmlns:a16="http://schemas.microsoft.com/office/drawing/2014/main" id="{72A80B44-4F45-4364-8A30-A0E13214D62A}"/>
+                <a16:creationId xmlns:a16="http://schemas.microsoft.com/office/drawing/2014/main" id="{47E892D5-3B9A-4021-9282-F6C42DF7F8CA}"/>
               </a:ext>
             </a:extLst>
           </p:cNvPr>
@@ -9780,7 +9780,7 @@
                 <a:ea typeface="Microsoft YaHei"/>
                 <a:cs typeface="Microsoft YaHei"/>
               </a:rPr>
-              <a:t>软件增量与接口联调</a:t>
+              <a:t>软件增量、数据初始化与接口联调</a:t>
             </a:r>
           </a:p>
           <a:p xmlns:a="http://schemas.openxmlformats.org/drawingml/2006/main">
@@ -9813,7 +9813,7 @@
           <p:cNvPr id="8" name="">
             <a:extLst xmlns:a="http://schemas.openxmlformats.org/drawingml/2006/main">
               <a:ext uri="{FF2B5EF4-FFF2-40B4-BE49-F238E27FC236}">
-                <a16:creationId xmlns:a16="http://schemas.microsoft.com/office/drawing/2014/main" id="{364AF196-3D7C-4468-A3E2-7564208A93C3}"/>
+                <a16:creationId xmlns:a16="http://schemas.microsoft.com/office/drawing/2014/main" id="{4B33CFF0-C4C9-44E2-87AE-51086A0C1156}"/>
               </a:ext>
             </a:extLst>
           </p:cNvPr>
@@ -9876,7 +9876,7 @@
           <p:cNvPr id="9" name="">
             <a:extLst xmlns:a="http://schemas.openxmlformats.org/drawingml/2006/main">
               <a:ext uri="{FF2B5EF4-FFF2-40B4-BE49-F238E27FC236}">
-                <a16:creationId xmlns:a16="http://schemas.microsoft.com/office/drawing/2014/main" id="{84409BEE-2834-4944-8D47-5B9DF4FF01C6}"/>
+                <a16:creationId xmlns:a16="http://schemas.microsoft.com/office/drawing/2014/main" id="{49B94B2A-C62C-4C37-9572-25FE24024273}"/>
               </a:ext>
             </a:extLst>
           </p:cNvPr>
@@ -9985,7 +9985,7 @@
           <p:cNvPr id="10" name="">
             <a:extLst xmlns:a="http://schemas.openxmlformats.org/drawingml/2006/main">
               <a:ext uri="{FF2B5EF4-FFF2-40B4-BE49-F238E27FC236}">
-                <a16:creationId xmlns:a16="http://schemas.microsoft.com/office/drawing/2014/main" id="{6EDD451E-8B2C-4ECB-A539-C0603339F24C}"/>
+                <a16:creationId xmlns:a16="http://schemas.microsoft.com/office/drawing/2014/main" id="{5E06CB14-8E58-4F47-A3E9-175A27D3C4D9}"/>
               </a:ext>
             </a:extLst>
           </p:cNvPr>
@@ -10042,7 +10042,7 @@
           <p:cNvPr id="11" name="">
             <a:extLst xmlns:a="http://schemas.openxmlformats.org/drawingml/2006/main">
               <a:ext uri="{FF2B5EF4-FFF2-40B4-BE49-F238E27FC236}">
-                <a16:creationId xmlns:a16="http://schemas.microsoft.com/office/drawing/2014/main" id="{74850D36-B0CE-4310-B5B1-FB008FF299B0}"/>
+                <a16:creationId xmlns:a16="http://schemas.microsoft.com/office/drawing/2014/main" id="{7BDE871A-438A-45E7-966B-7722221A7ADF}"/>
               </a:ext>
             </a:extLst>
           </p:cNvPr>
@@ -10099,7 +10099,7 @@
           <p:cNvPr id="12" name="">
             <a:extLst xmlns:a="http://schemas.openxmlformats.org/drawingml/2006/main">
               <a:ext uri="{FF2B5EF4-FFF2-40B4-BE49-F238E27FC236}">
-                <a16:creationId xmlns:a16="http://schemas.microsoft.com/office/drawing/2014/main" id="{DE65F149-2138-4AFE-BF40-9F2F396984A8}"/>
+                <a16:creationId xmlns:a16="http://schemas.microsoft.com/office/drawing/2014/main" id="{E062F207-5D2F-40EC-A0BC-EB0DCB41A0C9}"/>
               </a:ext>
             </a:extLst>
           </p:cNvPr>
@@ -10156,7 +10156,7 @@
           <p:cNvPr id="13" name="">
             <a:extLst xmlns:a="http://schemas.openxmlformats.org/drawingml/2006/main">
               <a:ext uri="{FF2B5EF4-FFF2-40B4-BE49-F238E27FC236}">
-                <a16:creationId xmlns:a16="http://schemas.microsoft.com/office/drawing/2014/main" id="{8FB77150-2953-449A-AD4C-CCF2093DE74E}"/>
+                <a16:creationId xmlns:a16="http://schemas.microsoft.com/office/drawing/2014/main" id="{DF35BC85-DAA2-44C2-8712-815AEC1FE889}"/>
               </a:ext>
             </a:extLst>
           </p:cNvPr>
@@ -10186,7 +10186,7 @@
           <p:cNvPr id="14" name="">
             <a:extLst xmlns:a="http://schemas.openxmlformats.org/drawingml/2006/main">
               <a:ext uri="{FF2B5EF4-FFF2-40B4-BE49-F238E27FC236}">
-                <a16:creationId xmlns:a16="http://schemas.microsoft.com/office/drawing/2014/main" id="{F00776BE-62D5-421B-AD77-17D68129F125}"/>
+                <a16:creationId xmlns:a16="http://schemas.microsoft.com/office/drawing/2014/main" id="{E6587BDD-1628-46C4-97C9-D9143E6191CA}"/>
               </a:ext>
             </a:extLst>
           </p:cNvPr>
@@ -10249,7 +10249,7 @@
           <p:cNvPr id="15" name="">
             <a:extLst xmlns:a="http://schemas.openxmlformats.org/drawingml/2006/main">
               <a:ext uri="{FF2B5EF4-FFF2-40B4-BE49-F238E27FC236}">
-                <a16:creationId xmlns:a16="http://schemas.microsoft.com/office/drawing/2014/main" id="{57DB42D7-176D-45E5-B2CD-D195F2B8E173}"/>
+                <a16:creationId xmlns:a16="http://schemas.microsoft.com/office/drawing/2014/main" id="{D4959A18-3BCC-4D0E-A109-186E4AE8640D}"/>
               </a:ext>
             </a:extLst>
           </p:cNvPr>
@@ -10306,7 +10306,7 @@
           <p:cNvPr id="16" name="">
             <a:extLst xmlns:a="http://schemas.openxmlformats.org/drawingml/2006/main">
               <a:ext uri="{FF2B5EF4-FFF2-40B4-BE49-F238E27FC236}">
-                <a16:creationId xmlns:a16="http://schemas.microsoft.com/office/drawing/2014/main" id="{15250575-A8C5-4C9A-A201-CFEC5E063DD4}"/>
+                <a16:creationId xmlns:a16="http://schemas.microsoft.com/office/drawing/2014/main" id="{E789506B-00E1-41A4-994E-0F54F9CCECCF}"/>
               </a:ext>
             </a:extLst>
           </p:cNvPr>
@@ -10369,7 +10369,7 @@
           <p:cNvPr id="17" name="">
             <a:extLst xmlns:a="http://schemas.openxmlformats.org/drawingml/2006/main">
               <a:ext uri="{FF2B5EF4-FFF2-40B4-BE49-F238E27FC236}">
-                <a16:creationId xmlns:a16="http://schemas.microsoft.com/office/drawing/2014/main" id="{702A5C3B-553D-44A3-A1F2-E34FBA668861}"/>
+                <a16:creationId xmlns:a16="http://schemas.microsoft.com/office/drawing/2014/main" id="{0E79A4D6-0F59-481F-8874-BDC0C20F3B85}"/>
               </a:ext>
             </a:extLst>
           </p:cNvPr>
@@ -10426,7 +10426,7 @@
           <p:cNvPr id="18" name="">
             <a:extLst xmlns:a="http://schemas.openxmlformats.org/drawingml/2006/main">
               <a:ext uri="{FF2B5EF4-FFF2-40B4-BE49-F238E27FC236}">
-                <a16:creationId xmlns:a16="http://schemas.microsoft.com/office/drawing/2014/main" id="{E0C9F2F5-0901-4585-8D29-480D836E0622}"/>
+                <a16:creationId xmlns:a16="http://schemas.microsoft.com/office/drawing/2014/main" id="{BCDC0554-3F43-4821-A8E1-914F7A38BFE1}"/>
               </a:ext>
             </a:extLst>
           </p:cNvPr>
@@ -10489,7 +10489,7 @@
           <p:cNvPr id="19" name="">
             <a:extLst xmlns:a="http://schemas.openxmlformats.org/drawingml/2006/main">
               <a:ext uri="{FF2B5EF4-FFF2-40B4-BE49-F238E27FC236}">
-                <a16:creationId xmlns:a16="http://schemas.microsoft.com/office/drawing/2014/main" id="{5FC7B94B-92B9-4656-A2E5-5C0B44BAD662}"/>
+                <a16:creationId xmlns:a16="http://schemas.microsoft.com/office/drawing/2014/main" id="{4CA668F9-C348-4630-8ED5-3C0CED8E9888}"/>
               </a:ext>
             </a:extLst>
           </p:cNvPr>
@@ -10546,7 +10546,7 @@
           <p:cNvPr id="20" name="">
             <a:extLst xmlns:a="http://schemas.openxmlformats.org/drawingml/2006/main">
               <a:ext uri="{FF2B5EF4-FFF2-40B4-BE49-F238E27FC236}">
-                <a16:creationId xmlns:a16="http://schemas.microsoft.com/office/drawing/2014/main" id="{153CA8D8-D6D4-4625-8477-BA205B4782DA}"/>
+                <a16:creationId xmlns:a16="http://schemas.microsoft.com/office/drawing/2014/main" id="{716C6309-5DFC-4453-8EE2-6CE1794C5B03}"/>
               </a:ext>
             </a:extLst>
           </p:cNvPr>
@@ -10609,7 +10609,7 @@
           <p:cNvPr id="21" name="">
             <a:extLst xmlns:a="http://schemas.openxmlformats.org/drawingml/2006/main">
               <a:ext uri="{FF2B5EF4-FFF2-40B4-BE49-F238E27FC236}">
-                <a16:creationId xmlns:a16="http://schemas.microsoft.com/office/drawing/2014/main" id="{C1299CA7-F646-49A3-A394-029706D5CE0F}"/>
+                <a16:creationId xmlns:a16="http://schemas.microsoft.com/office/drawing/2014/main" id="{1D82D56F-9088-415A-A4E4-48D62F69DD10}"/>
               </a:ext>
             </a:extLst>
           </p:cNvPr>
@@ -10666,7 +10666,7 @@
           <p:cNvPr id="22" name="">
             <a:extLst xmlns:a="http://schemas.openxmlformats.org/drawingml/2006/main">
               <a:ext uri="{FF2B5EF4-FFF2-40B4-BE49-F238E27FC236}">
-                <a16:creationId xmlns:a16="http://schemas.microsoft.com/office/drawing/2014/main" id="{52F04A85-001A-4D5D-8D54-6D7A31E572D5}"/>
+                <a16:creationId xmlns:a16="http://schemas.microsoft.com/office/drawing/2014/main" id="{B08DA2DF-CA6A-408E-825D-349376FB4A63}"/>
               </a:ext>
             </a:extLst>
           </p:cNvPr>
@@ -10721,7 +10721,7 @@
     </p:spTree>
     <p:extLst>
       <p:ext uri="{BB962C8B-B14F-4D97-AF65-F5344CB8AC3E}">
-        <p14:creationId xmlns:p14="http://schemas.microsoft.com/office/powerpoint/2010/main" val="1173704797"/>
+        <p14:creationId xmlns:p14="http://schemas.microsoft.com/office/powerpoint/2010/main" val="669397705"/>
       </p:ext>
     </p:extLst>
   </p:cSld>

</xml_diff>

<commit_message>
docs(G1-06): close remaining plan rework findings
</commit_message>
<xml_diff>
--- a/docs/work/A_PM/project_plan_v1_figures.pptx
+++ b/docs/work/A_PM/project_plan_v1_figures.pptx
@@ -1396,6 +1396,10 @@
             <a:noFill/>
           </a:ln>
         </p:spPr>
+        <p:txBody xmlns:a="http://schemas.openxmlformats.org/drawingml/2006/main">
+          <a:bodyPr/>
+          <a:p/>
+        </p:txBody>
       </p:sp>
       <p:sp>
         <p:nvSpPr>
@@ -1489,6 +1493,10 @@
             <a:noFill/>
           </a:ln>
         </p:spPr>
+        <p:txBody xmlns:a="http://schemas.openxmlformats.org/drawingml/2006/main">
+          <a:bodyPr/>
+          <a:p/>
+        </p:txBody>
       </p:sp>
       <p:sp>
         <p:nvSpPr>
@@ -1582,6 +1590,10 @@
             <a:noFill/>
           </a:ln>
         </p:spPr>
+        <p:txBody xmlns:a="http://schemas.openxmlformats.org/drawingml/2006/main">
+          <a:bodyPr/>
+          <a:p/>
+        </p:txBody>
       </p:sp>
       <p:sp>
         <p:nvSpPr>
@@ -1675,6 +1687,10 @@
             <a:noFill/>
           </a:ln>
         </p:spPr>
+        <p:txBody xmlns:a="http://schemas.openxmlformats.org/drawingml/2006/main">
+          <a:bodyPr/>
+          <a:p/>
+        </p:txBody>
       </p:sp>
       <p:sp>
         <p:nvSpPr>
@@ -1831,6 +1847,10 @@
             <a:noFill/>
           </a:ln>
         </p:spPr>
+        <p:txBody xmlns:a="http://schemas.openxmlformats.org/drawingml/2006/main">
+          <a:bodyPr/>
+          <a:p/>
+        </p:txBody>
       </p:sp>
       <p:sp>
         <p:nvSpPr>
@@ -1924,6 +1944,10 @@
             <a:noFill/>
           </a:ln>
         </p:spPr>
+        <p:txBody xmlns:a="http://schemas.openxmlformats.org/drawingml/2006/main">
+          <a:bodyPr/>
+          <a:p/>
+        </p:txBody>
       </p:sp>
       <p:sp>
         <p:nvSpPr>
@@ -2017,6 +2041,10 @@
             <a:noFill/>
           </a:ln>
         </p:spPr>
+        <p:txBody xmlns:a="http://schemas.openxmlformats.org/drawingml/2006/main">
+          <a:bodyPr/>
+          <a:p/>
+        </p:txBody>
       </p:sp>
       <p:sp>
         <p:nvSpPr>
@@ -2173,6 +2201,10 @@
             <a:noFill/>
           </a:ln>
         </p:spPr>
+        <p:txBody xmlns:a="http://schemas.openxmlformats.org/drawingml/2006/main">
+          <a:bodyPr/>
+          <a:p/>
+        </p:txBody>
       </p:sp>
       <p:sp>
         <p:nvSpPr>
@@ -2266,6 +2298,10 @@
             <a:noFill/>
           </a:ln>
         </p:spPr>
+        <p:txBody xmlns:a="http://schemas.openxmlformats.org/drawingml/2006/main">
+          <a:bodyPr/>
+          <a:p/>
+        </p:txBody>
       </p:sp>
       <p:sp>
         <p:nvSpPr>
@@ -2359,6 +2395,10 @@
             <a:noFill/>
           </a:ln>
         </p:spPr>
+        <p:txBody xmlns:a="http://schemas.openxmlformats.org/drawingml/2006/main">
+          <a:bodyPr/>
+          <a:p/>
+        </p:txBody>
       </p:sp>
       <p:sp>
         <p:nvSpPr>
@@ -2515,6 +2555,10 @@
             <a:noFill/>
           </a:ln>
         </p:spPr>
+        <p:txBody xmlns:a="http://schemas.openxmlformats.org/drawingml/2006/main">
+          <a:bodyPr/>
+          <a:p/>
+        </p:txBody>
       </p:sp>
       <p:sp>
         <p:nvSpPr>
@@ -2608,6 +2652,10 @@
             <a:noFill/>
           </a:ln>
         </p:spPr>
+        <p:txBody xmlns:a="http://schemas.openxmlformats.org/drawingml/2006/main">
+          <a:bodyPr/>
+          <a:p/>
+        </p:txBody>
       </p:sp>
       <p:sp>
         <p:nvSpPr>
@@ -2701,6 +2749,10 @@
             <a:noFill/>
           </a:ln>
         </p:spPr>
+        <p:txBody xmlns:a="http://schemas.openxmlformats.org/drawingml/2006/main">
+          <a:bodyPr/>
+          <a:p/>
+        </p:txBody>
       </p:sp>
       <p:sp>
         <p:nvSpPr>
@@ -2857,6 +2909,10 @@
             <a:noFill/>
           </a:ln>
         </p:spPr>
+        <p:txBody xmlns:a="http://schemas.openxmlformats.org/drawingml/2006/main">
+          <a:bodyPr/>
+          <a:p/>
+        </p:txBody>
       </p:sp>
       <p:sp>
         <p:nvSpPr>
@@ -2950,6 +3006,10 @@
             <a:noFill/>
           </a:ln>
         </p:spPr>
+        <p:txBody xmlns:a="http://schemas.openxmlformats.org/drawingml/2006/main">
+          <a:bodyPr/>
+          <a:p/>
+        </p:txBody>
       </p:sp>
       <p:sp>
         <p:nvSpPr>
@@ -3043,6 +3103,10 @@
             <a:noFill/>
           </a:ln>
         </p:spPr>
+        <p:txBody xmlns:a="http://schemas.openxmlformats.org/drawingml/2006/main">
+          <a:bodyPr/>
+          <a:p/>
+        </p:txBody>
       </p:sp>
       <p:sp>
         <p:nvSpPr>
@@ -3199,6 +3263,10 @@
             <a:noFill/>
           </a:ln>
         </p:spPr>
+        <p:txBody xmlns:a="http://schemas.openxmlformats.org/drawingml/2006/main">
+          <a:bodyPr/>
+          <a:p/>
+        </p:txBody>
       </p:sp>
       <p:sp>
         <p:nvSpPr>
@@ -3292,6 +3360,10 @@
             <a:noFill/>
           </a:ln>
         </p:spPr>
+        <p:txBody xmlns:a="http://schemas.openxmlformats.org/drawingml/2006/main">
+          <a:bodyPr/>
+          <a:p/>
+        </p:txBody>
       </p:sp>
       <p:sp>
         <p:nvSpPr>
@@ -3385,6 +3457,10 @@
             <a:noFill/>
           </a:ln>
         </p:spPr>
+        <p:txBody xmlns:a="http://schemas.openxmlformats.org/drawingml/2006/main">
+          <a:bodyPr/>
+          <a:p/>
+        </p:txBody>
       </p:sp>
       <p:sp>
         <p:nvSpPr>
@@ -3735,6 +3811,10 @@
             <a:noFill/>
           </a:ln>
         </p:spPr>
+        <p:txBody xmlns:a="http://schemas.openxmlformats.org/drawingml/2006/main">
+          <a:bodyPr/>
+          <a:p/>
+        </p:txBody>
       </p:sp>
       <p:sp>
         <p:nvSpPr>
@@ -3765,6 +3845,10 @@
             <a:noFill/>
           </a:ln>
         </p:spPr>
+        <p:txBody xmlns:a="http://schemas.openxmlformats.org/drawingml/2006/main">
+          <a:bodyPr/>
+          <a:p/>
+        </p:txBody>
       </p:sp>
       <p:sp>
         <p:nvSpPr>
@@ -3797,6 +3881,10 @@
             </a:solidFill>
           </a:ln>
         </p:spPr>
+        <p:txBody xmlns:a="http://schemas.openxmlformats.org/drawingml/2006/main">
+          <a:bodyPr/>
+          <a:p/>
+        </p:txBody>
       </p:sp>
       <p:sp>
         <p:nvSpPr>
@@ -4086,6 +4174,10 @@
             </a:solidFill>
           </a:ln>
         </p:spPr>
+        <p:txBody xmlns:a="http://schemas.openxmlformats.org/drawingml/2006/main">
+          <a:bodyPr/>
+          <a:p/>
+        </p:txBody>
       </p:sp>
       <p:sp>
         <p:nvSpPr>
@@ -4375,6 +4467,10 @@
             </a:solidFill>
           </a:ln>
         </p:spPr>
+        <p:txBody xmlns:a="http://schemas.openxmlformats.org/drawingml/2006/main">
+          <a:bodyPr/>
+          <a:p/>
+        </p:txBody>
       </p:sp>
       <p:sp>
         <p:nvSpPr>
@@ -4664,6 +4760,10 @@
             </a:solidFill>
           </a:ln>
         </p:spPr>
+        <p:txBody xmlns:a="http://schemas.openxmlformats.org/drawingml/2006/main">
+          <a:bodyPr/>
+          <a:p/>
+        </p:txBody>
       </p:sp>
       <p:sp>
         <p:nvSpPr>
@@ -4953,6 +5053,10 @@
             </a:solidFill>
           </a:ln>
         </p:spPr>
+        <p:txBody xmlns:a="http://schemas.openxmlformats.org/drawingml/2006/main">
+          <a:bodyPr/>
+          <a:p/>
+        </p:txBody>
       </p:sp>
       <p:sp>
         <p:nvSpPr>
@@ -5269,7 +5373,7 @@
                 <a:ea typeface="Microsoft YaHei"/>
                 <a:cs typeface="Microsoft YaHei"/>
               </a:rPr>
-              <a:t>W17—W20均形成运行监测、工单、缺陷和可用率证据。W20先完成M4试运行准出，再组织M5竣工验收；甲方验收窗口变化不降低准出条件。</a:t>
+              <a:t>M3初验后形成试运行启动记录并立即连续监测；W17培训与监测并行。W17—W20均形成运行、工单、缺陷和可用率证据；W20先M4准出，再组织M5。</a:t>
             </a:r>
           </a:p>
         </p:txBody>
@@ -5503,6 +5607,10 @@
             <a:noFill/>
           </a:ln>
         </p:spPr>
+        <p:txBody xmlns:a="http://schemas.openxmlformats.org/drawingml/2006/main">
+          <a:bodyPr/>
+          <a:p/>
+        </p:txBody>
       </p:sp>
       <p:sp>
         <p:nvSpPr>
@@ -5647,6 +5755,10 @@
             <a:noFill/>
           </a:ln>
         </p:spPr>
+        <p:txBody xmlns:a="http://schemas.openxmlformats.org/drawingml/2006/main">
+          <a:bodyPr/>
+          <a:p/>
+        </p:txBody>
       </p:sp>
       <p:sp>
         <p:nvSpPr>
@@ -5734,6 +5846,10 @@
             <a:noFill/>
           </a:ln>
         </p:spPr>
+        <p:txBody xmlns:a="http://schemas.openxmlformats.org/drawingml/2006/main">
+          <a:bodyPr/>
+          <a:p/>
+        </p:txBody>
       </p:sp>
       <p:sp>
         <p:nvSpPr>
@@ -5821,6 +5937,10 @@
             <a:noFill/>
           </a:ln>
         </p:spPr>
+        <p:txBody xmlns:a="http://schemas.openxmlformats.org/drawingml/2006/main">
+          <a:bodyPr/>
+          <a:p/>
+        </p:txBody>
       </p:sp>
       <p:sp>
         <p:nvSpPr>
@@ -5908,6 +6028,10 @@
             <a:noFill/>
           </a:ln>
         </p:spPr>
+        <p:txBody xmlns:a="http://schemas.openxmlformats.org/drawingml/2006/main">
+          <a:bodyPr/>
+          <a:p/>
+        </p:txBody>
       </p:sp>
       <p:sp>
         <p:nvSpPr>
@@ -5995,6 +6119,10 @@
             <a:noFill/>
           </a:ln>
         </p:spPr>
+        <p:txBody xmlns:a="http://schemas.openxmlformats.org/drawingml/2006/main">
+          <a:bodyPr/>
+          <a:p/>
+        </p:txBody>
       </p:sp>
       <p:sp>
         <p:nvSpPr>
@@ -6082,6 +6210,10 @@
             <a:noFill/>
           </a:ln>
         </p:spPr>
+        <p:txBody xmlns:a="http://schemas.openxmlformats.org/drawingml/2006/main">
+          <a:bodyPr/>
+          <a:p/>
+        </p:txBody>
       </p:sp>
       <p:sp>
         <p:nvSpPr>
@@ -6169,6 +6301,10 @@
             <a:noFill/>
           </a:ln>
         </p:spPr>
+        <p:txBody xmlns:a="http://schemas.openxmlformats.org/drawingml/2006/main">
+          <a:bodyPr/>
+          <a:p/>
+        </p:txBody>
       </p:sp>
       <p:sp>
         <p:nvSpPr>
@@ -6256,6 +6392,10 @@
             <a:noFill/>
           </a:ln>
         </p:spPr>
+        <p:txBody xmlns:a="http://schemas.openxmlformats.org/drawingml/2006/main">
+          <a:bodyPr/>
+          <a:p/>
+        </p:txBody>
       </p:sp>
       <p:sp>
         <p:nvSpPr>
@@ -6343,6 +6483,10 @@
             <a:noFill/>
           </a:ln>
         </p:spPr>
+        <p:txBody xmlns:a="http://schemas.openxmlformats.org/drawingml/2006/main">
+          <a:bodyPr/>
+          <a:p/>
+        </p:txBody>
       </p:sp>
       <p:sp>
         <p:nvSpPr>
@@ -6430,6 +6574,10 @@
             <a:noFill/>
           </a:ln>
         </p:spPr>
+        <p:txBody xmlns:a="http://schemas.openxmlformats.org/drawingml/2006/main">
+          <a:bodyPr/>
+          <a:p/>
+        </p:txBody>
       </p:sp>
       <p:sp>
         <p:nvSpPr>
@@ -6517,6 +6665,10 @@
             <a:noFill/>
           </a:ln>
         </p:spPr>
+        <p:txBody xmlns:a="http://schemas.openxmlformats.org/drawingml/2006/main">
+          <a:bodyPr/>
+          <a:p/>
+        </p:txBody>
       </p:sp>
       <p:sp>
         <p:nvSpPr>
@@ -6604,6 +6756,10 @@
             <a:noFill/>
           </a:ln>
         </p:spPr>
+        <p:txBody xmlns:a="http://schemas.openxmlformats.org/drawingml/2006/main">
+          <a:bodyPr/>
+          <a:p/>
+        </p:txBody>
       </p:sp>
       <p:sp>
         <p:nvSpPr>
@@ -6691,6 +6847,10 @@
             <a:noFill/>
           </a:ln>
         </p:spPr>
+        <p:txBody xmlns:a="http://schemas.openxmlformats.org/drawingml/2006/main">
+          <a:bodyPr/>
+          <a:p/>
+        </p:txBody>
       </p:sp>
       <p:sp>
         <p:nvSpPr>
@@ -6778,6 +6938,10 @@
             <a:noFill/>
           </a:ln>
         </p:spPr>
+        <p:txBody xmlns:a="http://schemas.openxmlformats.org/drawingml/2006/main">
+          <a:bodyPr/>
+          <a:p/>
+        </p:txBody>
       </p:sp>
       <p:sp>
         <p:nvSpPr>
@@ -6865,6 +7029,10 @@
             <a:noFill/>
           </a:ln>
         </p:spPr>
+        <p:txBody xmlns:a="http://schemas.openxmlformats.org/drawingml/2006/main">
+          <a:bodyPr/>
+          <a:p/>
+        </p:txBody>
       </p:sp>
       <p:sp>
         <p:nvSpPr>
@@ -6952,6 +7120,10 @@
             <a:noFill/>
           </a:ln>
         </p:spPr>
+        <p:txBody xmlns:a="http://schemas.openxmlformats.org/drawingml/2006/main">
+          <a:bodyPr/>
+          <a:p/>
+        </p:txBody>
       </p:sp>
       <p:sp>
         <p:nvSpPr>
@@ -7039,6 +7211,10 @@
             <a:noFill/>
           </a:ln>
         </p:spPr>
+        <p:txBody xmlns:a="http://schemas.openxmlformats.org/drawingml/2006/main">
+          <a:bodyPr/>
+          <a:p/>
+        </p:txBody>
       </p:sp>
       <p:sp>
         <p:nvSpPr>
@@ -7126,6 +7302,10 @@
             <a:noFill/>
           </a:ln>
         </p:spPr>
+        <p:txBody xmlns:a="http://schemas.openxmlformats.org/drawingml/2006/main">
+          <a:bodyPr/>
+          <a:p/>
+        </p:txBody>
       </p:sp>
       <p:sp>
         <p:nvSpPr>
@@ -7213,6 +7393,10 @@
             <a:noFill/>
           </a:ln>
         </p:spPr>
+        <p:txBody xmlns:a="http://schemas.openxmlformats.org/drawingml/2006/main">
+          <a:bodyPr/>
+          <a:p/>
+        </p:txBody>
       </p:sp>
       <p:sp>
         <p:nvSpPr>
@@ -7300,6 +7484,10 @@
             <a:noFill/>
           </a:ln>
         </p:spPr>
+        <p:txBody xmlns:a="http://schemas.openxmlformats.org/drawingml/2006/main">
+          <a:bodyPr/>
+          <a:p/>
+        </p:txBody>
       </p:sp>
       <p:sp>
         <p:nvSpPr>
@@ -7330,6 +7518,10 @@
             <a:noFill/>
           </a:ln>
         </p:spPr>
+        <p:txBody xmlns:a="http://schemas.openxmlformats.org/drawingml/2006/main">
+          <a:bodyPr/>
+          <a:p/>
+        </p:txBody>
       </p:sp>
       <p:sp>
         <p:nvSpPr>
@@ -7417,6 +7609,10 @@
             <a:noFill/>
           </a:ln>
         </p:spPr>
+        <p:txBody xmlns:a="http://schemas.openxmlformats.org/drawingml/2006/main">
+          <a:bodyPr/>
+          <a:p/>
+        </p:txBody>
       </p:sp>
       <p:sp>
         <p:nvSpPr>
@@ -7449,6 +7645,10 @@
             </a:solidFill>
           </a:ln>
         </p:spPr>
+        <p:txBody xmlns:a="http://schemas.openxmlformats.org/drawingml/2006/main">
+          <a:bodyPr/>
+          <a:p/>
+        </p:txBody>
       </p:sp>
       <p:sp>
         <p:nvSpPr>
@@ -7536,6 +7736,10 @@
             <a:noFill/>
           </a:ln>
         </p:spPr>
+        <p:txBody xmlns:a="http://schemas.openxmlformats.org/drawingml/2006/main">
+          <a:bodyPr/>
+          <a:p/>
+        </p:txBody>
       </p:sp>
       <p:sp>
         <p:nvSpPr>
@@ -7568,6 +7772,10 @@
             </a:solidFill>
           </a:ln>
         </p:spPr>
+        <p:txBody xmlns:a="http://schemas.openxmlformats.org/drawingml/2006/main">
+          <a:bodyPr/>
+          <a:p/>
+        </p:txBody>
       </p:sp>
       <p:sp>
         <p:nvSpPr>
@@ -7655,6 +7863,10 @@
             <a:noFill/>
           </a:ln>
         </p:spPr>
+        <p:txBody xmlns:a="http://schemas.openxmlformats.org/drawingml/2006/main">
+          <a:bodyPr/>
+          <a:p/>
+        </p:txBody>
       </p:sp>
       <p:sp>
         <p:nvSpPr>
@@ -7687,6 +7899,10 @@
             </a:solidFill>
           </a:ln>
         </p:spPr>
+        <p:txBody xmlns:a="http://schemas.openxmlformats.org/drawingml/2006/main">
+          <a:bodyPr/>
+          <a:p/>
+        </p:txBody>
       </p:sp>
       <p:sp>
         <p:nvSpPr>
@@ -7774,6 +7990,10 @@
             <a:noFill/>
           </a:ln>
         </p:spPr>
+        <p:txBody xmlns:a="http://schemas.openxmlformats.org/drawingml/2006/main">
+          <a:bodyPr/>
+          <a:p/>
+        </p:txBody>
       </p:sp>
       <p:sp>
         <p:nvSpPr>
@@ -7806,6 +8026,10 @@
             </a:solidFill>
           </a:ln>
         </p:spPr>
+        <p:txBody xmlns:a="http://schemas.openxmlformats.org/drawingml/2006/main">
+          <a:bodyPr/>
+          <a:p/>
+        </p:txBody>
       </p:sp>
       <p:sp>
         <p:nvSpPr>
@@ -7893,6 +8117,10 @@
             <a:noFill/>
           </a:ln>
         </p:spPr>
+        <p:txBody xmlns:a="http://schemas.openxmlformats.org/drawingml/2006/main">
+          <a:bodyPr/>
+          <a:p/>
+        </p:txBody>
       </p:sp>
       <p:sp>
         <p:nvSpPr>
@@ -7925,6 +8153,10 @@
             </a:solidFill>
           </a:ln>
         </p:spPr>
+        <p:txBody xmlns:a="http://schemas.openxmlformats.org/drawingml/2006/main">
+          <a:bodyPr/>
+          <a:p/>
+        </p:txBody>
       </p:sp>
       <p:sp>
         <p:nvSpPr>
@@ -8012,6 +8244,10 @@
             <a:noFill/>
           </a:ln>
         </p:spPr>
+        <p:txBody xmlns:a="http://schemas.openxmlformats.org/drawingml/2006/main">
+          <a:bodyPr/>
+          <a:p/>
+        </p:txBody>
       </p:sp>
       <p:sp>
         <p:nvSpPr>
@@ -8044,6 +8280,10 @@
             </a:solidFill>
           </a:ln>
         </p:spPr>
+        <p:txBody xmlns:a="http://schemas.openxmlformats.org/drawingml/2006/main">
+          <a:bodyPr/>
+          <a:p/>
+        </p:txBody>
       </p:sp>
       <p:sp>
         <p:nvSpPr>
@@ -8131,6 +8371,10 @@
             <a:noFill/>
           </a:ln>
         </p:spPr>
+        <p:txBody xmlns:a="http://schemas.openxmlformats.org/drawingml/2006/main">
+          <a:bodyPr/>
+          <a:p/>
+        </p:txBody>
       </p:sp>
       <p:sp>
         <p:nvSpPr>
@@ -8163,6 +8407,10 @@
             </a:solidFill>
           </a:ln>
         </p:spPr>
+        <p:txBody xmlns:a="http://schemas.openxmlformats.org/drawingml/2006/main">
+          <a:bodyPr/>
+          <a:p/>
+        </p:txBody>
       </p:sp>
       <p:sp>
         <p:nvSpPr>
@@ -8250,6 +8498,10 @@
             <a:noFill/>
           </a:ln>
         </p:spPr>
+        <p:txBody xmlns:a="http://schemas.openxmlformats.org/drawingml/2006/main">
+          <a:bodyPr/>
+          <a:p/>
+        </p:txBody>
       </p:sp>
       <p:sp>
         <p:nvSpPr>
@@ -8282,6 +8534,10 @@
             </a:solidFill>
           </a:ln>
         </p:spPr>
+        <p:txBody xmlns:a="http://schemas.openxmlformats.org/drawingml/2006/main">
+          <a:bodyPr/>
+          <a:p/>
+        </p:txBody>
       </p:sp>
       <p:sp>
         <p:nvSpPr>
@@ -8369,6 +8625,10 @@
             <a:noFill/>
           </a:ln>
         </p:spPr>
+        <p:txBody xmlns:a="http://schemas.openxmlformats.org/drawingml/2006/main">
+          <a:bodyPr/>
+          <a:p/>
+        </p:txBody>
       </p:sp>
       <p:sp>
         <p:nvSpPr>
@@ -8401,6 +8661,10 @@
             </a:solidFill>
           </a:ln>
         </p:spPr>
+        <p:txBody xmlns:a="http://schemas.openxmlformats.org/drawingml/2006/main">
+          <a:bodyPr/>
+          <a:p/>
+        </p:txBody>
       </p:sp>
       <p:sp>
         <p:nvSpPr>
@@ -8488,6 +8752,10 @@
             <a:noFill/>
           </a:ln>
         </p:spPr>
+        <p:txBody xmlns:a="http://schemas.openxmlformats.org/drawingml/2006/main">
+          <a:bodyPr/>
+          <a:p/>
+        </p:txBody>
       </p:sp>
       <p:sp>
         <p:nvSpPr>
@@ -8520,6 +8788,10 @@
             </a:solidFill>
           </a:ln>
         </p:spPr>
+        <p:txBody xmlns:a="http://schemas.openxmlformats.org/drawingml/2006/main">
+          <a:bodyPr/>
+          <a:p/>
+        </p:txBody>
       </p:sp>
       <p:sp>
         <p:nvSpPr>
@@ -8607,6 +8879,10 @@
             <a:noFill/>
           </a:ln>
         </p:spPr>
+        <p:txBody xmlns:a="http://schemas.openxmlformats.org/drawingml/2006/main">
+          <a:bodyPr/>
+          <a:p/>
+        </p:txBody>
       </p:sp>
       <p:sp>
         <p:nvSpPr>
@@ -8639,6 +8915,10 @@
             </a:solidFill>
           </a:ln>
         </p:spPr>
+        <p:txBody xmlns:a="http://schemas.openxmlformats.org/drawingml/2006/main">
+          <a:bodyPr/>
+          <a:p/>
+        </p:txBody>
       </p:sp>
       <p:sp>
         <p:nvSpPr>
@@ -8726,6 +9006,10 @@
             <a:noFill/>
           </a:ln>
         </p:spPr>
+        <p:txBody xmlns:a="http://schemas.openxmlformats.org/drawingml/2006/main">
+          <a:bodyPr/>
+          <a:p/>
+        </p:txBody>
       </p:sp>
       <p:sp>
         <p:nvSpPr>
@@ -8758,6 +9042,10 @@
             </a:solidFill>
           </a:ln>
         </p:spPr>
+        <p:txBody xmlns:a="http://schemas.openxmlformats.org/drawingml/2006/main">
+          <a:bodyPr/>
+          <a:p/>
+        </p:txBody>
       </p:sp>
       <p:sp>
         <p:nvSpPr>
@@ -8845,6 +9133,10 @@
             <a:noFill/>
           </a:ln>
         </p:spPr>
+        <p:txBody xmlns:a="http://schemas.openxmlformats.org/drawingml/2006/main">
+          <a:bodyPr/>
+          <a:p/>
+        </p:txBody>
       </p:sp>
       <p:sp>
         <p:nvSpPr>
@@ -8877,6 +9169,10 @@
             </a:solidFill>
           </a:ln>
         </p:spPr>
+        <p:txBody xmlns:a="http://schemas.openxmlformats.org/drawingml/2006/main">
+          <a:bodyPr/>
+          <a:p/>
+        </p:txBody>
       </p:sp>
       <p:sp>
         <p:nvSpPr>
@@ -8909,6 +9205,10 @@
             </a:solidFill>
           </a:ln>
         </p:spPr>
+        <p:txBody xmlns:a="http://schemas.openxmlformats.org/drawingml/2006/main">
+          <a:bodyPr/>
+          <a:p/>
+        </p:txBody>
       </p:sp>
       <p:sp>
         <p:nvSpPr>
@@ -8998,6 +9298,10 @@
             </a:solidFill>
           </a:ln>
         </p:spPr>
+        <p:txBody xmlns:a="http://schemas.openxmlformats.org/drawingml/2006/main">
+          <a:bodyPr/>
+          <a:p/>
+        </p:txBody>
       </p:sp>
       <p:sp>
         <p:nvSpPr>
@@ -9087,6 +9391,10 @@
             </a:solidFill>
           </a:ln>
         </p:spPr>
+        <p:txBody xmlns:a="http://schemas.openxmlformats.org/drawingml/2006/main">
+          <a:bodyPr/>
+          <a:p/>
+        </p:txBody>
       </p:sp>
       <p:sp>
         <p:nvSpPr>
@@ -9176,6 +9484,10 @@
             </a:solidFill>
           </a:ln>
         </p:spPr>
+        <p:txBody xmlns:a="http://schemas.openxmlformats.org/drawingml/2006/main">
+          <a:bodyPr/>
+          <a:p/>
+        </p:txBody>
       </p:sp>
       <p:sp>
         <p:nvSpPr>
@@ -9463,6 +9775,10 @@
             <a:noFill/>
           </a:ln>
         </p:spPr>
+        <p:txBody xmlns:a="http://schemas.openxmlformats.org/drawingml/2006/main">
+          <a:bodyPr/>
+          <a:p/>
+        </p:txBody>
       </p:sp>
       <p:sp>
         <p:nvSpPr>
@@ -10180,6 +10496,10 @@
             <a:noFill/>
           </a:ln>
         </p:spPr>
+        <p:txBody xmlns:a="http://schemas.openxmlformats.org/drawingml/2006/main">
+          <a:bodyPr/>
+          <a:p/>
+        </p:txBody>
       </p:sp>
       <p:sp>
         <p:nvSpPr>

</xml_diff>